<commit_message>
fix: enforce Phase 7B deck typography
</commit_message>
<xml_diff>
--- a/presentation/final_presentation.pptx
+++ b/presentation/final_presentation.pptx
@@ -2,22 +2,22 @@
 <file path=ppt/presentation.xml><?xml version="1.0" encoding="utf-8"?>
 <p:presentation xmlns:p="http://schemas.openxmlformats.org/presentationml/2006/main">
   <p:sldMasterIdLst>
-    <p:sldMasterId xmlns:r="http://schemas.openxmlformats.org/officeDocument/2006/relationships" id="2147483648" r:id="R91b9bc4654c944e7"/>
+    <p:sldMasterId xmlns:r="http://schemas.openxmlformats.org/officeDocument/2006/relationships" id="2147483648" r:id="Ra0deef59aef642df"/>
   </p:sldMasterIdLst>
   <p:notesMasterIdLst>
-    <p:notesMasterId xmlns:r="http://schemas.openxmlformats.org/officeDocument/2006/relationships" r:id="R7a8fe9ef97c14eba"/>
+    <p:notesMasterId xmlns:r="http://schemas.openxmlformats.org/officeDocument/2006/relationships" r:id="Rd50b4e1a4ab34741"/>
   </p:notesMasterIdLst>
   <p:sldIdLst>
-    <p:sldId xmlns:r="http://schemas.openxmlformats.org/officeDocument/2006/relationships" id="256" r:id="R6a7dd7a405d4414d"/>
-    <p:sldId xmlns:r="http://schemas.openxmlformats.org/officeDocument/2006/relationships" id="257" r:id="R2fe18287bb68442a"/>
-    <p:sldId xmlns:r="http://schemas.openxmlformats.org/officeDocument/2006/relationships" id="258" r:id="Rda1e3ec69fa74d61"/>
-    <p:sldId xmlns:r="http://schemas.openxmlformats.org/officeDocument/2006/relationships" id="259" r:id="R2edd7c92662b425e"/>
-    <p:sldId xmlns:r="http://schemas.openxmlformats.org/officeDocument/2006/relationships" id="260" r:id="R809a5314b63a45b7"/>
-    <p:sldId xmlns:r="http://schemas.openxmlformats.org/officeDocument/2006/relationships" id="261" r:id="Rcc3b5365a80640ea"/>
-    <p:sldId xmlns:r="http://schemas.openxmlformats.org/officeDocument/2006/relationships" id="262" r:id="Rad074e78a7004fab"/>
-    <p:sldId xmlns:r="http://schemas.openxmlformats.org/officeDocument/2006/relationships" id="263" r:id="Refd1313425034fa7"/>
-    <p:sldId xmlns:r="http://schemas.openxmlformats.org/officeDocument/2006/relationships" id="264" r:id="R140ca84f93e9419d"/>
-    <p:sldId xmlns:r="http://schemas.openxmlformats.org/officeDocument/2006/relationships" id="265" r:id="Rb55acbfce7a441e0"/>
+    <p:sldId xmlns:r="http://schemas.openxmlformats.org/officeDocument/2006/relationships" id="256" r:id="Rabe40c63e3184f96"/>
+    <p:sldId xmlns:r="http://schemas.openxmlformats.org/officeDocument/2006/relationships" id="257" r:id="R6ae6b776166a4999"/>
+    <p:sldId xmlns:r="http://schemas.openxmlformats.org/officeDocument/2006/relationships" id="258" r:id="R1067689edaac4dd2"/>
+    <p:sldId xmlns:r="http://schemas.openxmlformats.org/officeDocument/2006/relationships" id="259" r:id="R0baaca2a01144859"/>
+    <p:sldId xmlns:r="http://schemas.openxmlformats.org/officeDocument/2006/relationships" id="260" r:id="R547b818add27423b"/>
+    <p:sldId xmlns:r="http://schemas.openxmlformats.org/officeDocument/2006/relationships" id="261" r:id="R024574547ffd4058"/>
+    <p:sldId xmlns:r="http://schemas.openxmlformats.org/officeDocument/2006/relationships" id="262" r:id="R6dd6b0890c3e46b1"/>
+    <p:sldId xmlns:r="http://schemas.openxmlformats.org/officeDocument/2006/relationships" id="263" r:id="R0c4be0b8571b496b"/>
+    <p:sldId xmlns:r="http://schemas.openxmlformats.org/officeDocument/2006/relationships" id="264" r:id="R4580430688594fd0"/>
+    <p:sldId xmlns:r="http://schemas.openxmlformats.org/officeDocument/2006/relationships" id="265" r:id="R0535fd93e93d472d"/>
   </p:sldIdLst>
   <p:sldSz cx="12192000" cy="6858000"/>
   <p:notesSz cx="6858000" cy="9144000"/>
@@ -1374,7 +1374,7 @@
   </p:cSld>
   <p:clrMap bg1="lt1" tx1="dk1" bg2="lt2" tx2="dk2" accent1="accent1" accent2="accent2" accent3="accent3" accent4="accent4" accent5="accent5" accent6="accent6" hlink="hlink" folHlink="folHlink"/>
   <p:sldLayoutIdLst>
-    <p:sldLayoutId xmlns:r="http://schemas.openxmlformats.org/officeDocument/2006/relationships" id="2147483649" r:id="Rb6f8fafbf3b4466f"/>
+    <p:sldLayoutId xmlns:r="http://schemas.openxmlformats.org/officeDocument/2006/relationships" id="2147483649" r:id="R927f68adeef64656"/>
   </p:sldLayoutIdLst>
   <p:txStyles>
     <p:titleStyle>
@@ -1929,7 +1929,7 @@
           <p:nvPr/>
         </p:nvPicPr>
         <p:blipFill>
-          <a:blip xmlns:r="http://schemas.openxmlformats.org/officeDocument/2006/relationships" xmlns:a="http://schemas.openxmlformats.org/drawingml/2006/main" r:embed="R5f0efb149b924594"/>
+          <a:blip xmlns:r="http://schemas.openxmlformats.org/officeDocument/2006/relationships" xmlns:a="http://schemas.openxmlformats.org/drawingml/2006/main" r:embed="R0fd6e0a7140e4fa3"/>
           <a:stretch xmlns:a="http://schemas.openxmlformats.org/drawingml/2006/main"/>
         </p:blipFill>
         <p:spPr>
@@ -1947,7 +1947,7 @@
           <p:cNvPr id="2" name="cover-title">
             <a:extLst xmlns:a="http://schemas.openxmlformats.org/drawingml/2006/main">
               <a:ext uri="{FF2B5EF4-FFF2-40B4-BE49-F238E27FC236}">
-                <a16:creationId xmlns:a16="http://schemas.microsoft.com/office/drawing/2014/main" id="{7AF40C35-8299-4F3E-A324-3CC83A853BD2}"/>
+                <a16:creationId xmlns:a16="http://schemas.microsoft.com/office/drawing/2014/main" id="{E49DCBFA-49D5-428C-B554-6F3D9673F2F0}"/>
               </a:ext>
             </a:extLst>
           </p:cNvPr>
@@ -2005,7 +2005,7 @@
           <p:cNvPr id="3" name="cover-subtitle">
             <a:extLst xmlns:a="http://schemas.openxmlformats.org/drawingml/2006/main">
               <a:ext uri="{FF2B5EF4-FFF2-40B4-BE49-F238E27FC236}">
-                <a16:creationId xmlns:a16="http://schemas.microsoft.com/office/drawing/2014/main" id="{BB94103C-F0C9-46F2-8947-3FF613AC86BD}"/>
+                <a16:creationId xmlns:a16="http://schemas.microsoft.com/office/drawing/2014/main" id="{23D8E7CA-5125-4A5E-986D-806D0F62128B}"/>
               </a:ext>
             </a:extLst>
           </p:cNvPr>
@@ -2061,7 +2061,7 @@
     </p:spTree>
     <p:extLst>
       <p:ext uri="{BB962C8B-B14F-4D97-AF65-F5344CB8AC3E}">
-        <p14:creationId xmlns:p14="http://schemas.microsoft.com/office/powerpoint/2010/main" val="1995710902"/>
+        <p14:creationId xmlns:p14="http://schemas.microsoft.com/office/powerpoint/2010/main" val="710372222"/>
       </p:ext>
     </p:extLst>
   </p:cSld>
@@ -2092,7 +2092,7 @@
           <p:cNvPr id="4" name="slide-10-title">
             <a:extLst xmlns:a="http://schemas.openxmlformats.org/drawingml/2006/main">
               <a:ext uri="{FF2B5EF4-FFF2-40B4-BE49-F238E27FC236}">
-                <a16:creationId xmlns:a16="http://schemas.microsoft.com/office/drawing/2014/main" id="{EA0623AA-8B7E-4746-B4C1-75FCFD44647A}"/>
+                <a16:creationId xmlns:a16="http://schemas.microsoft.com/office/drawing/2014/main" id="{1B79B5AC-8500-4FE8-B7A6-EE614643CF1E}"/>
               </a:ext>
             </a:extLst>
           </p:cNvPr>
@@ -2150,7 +2150,7 @@
           <p:cNvPr id="2" name="next-steps-lead">
             <a:extLst xmlns:a="http://schemas.openxmlformats.org/drawingml/2006/main">
               <a:ext uri="{FF2B5EF4-FFF2-40B4-BE49-F238E27FC236}">
-                <a16:creationId xmlns:a16="http://schemas.microsoft.com/office/drawing/2014/main" id="{4D4766F3-A78A-4AE4-8212-30F7672D20C2}"/>
+                <a16:creationId xmlns:a16="http://schemas.microsoft.com/office/drawing/2014/main" id="{F91ECE79-5483-409A-8128-253686870520}"/>
               </a:ext>
             </a:extLst>
           </p:cNvPr>
@@ -2208,7 +2208,7 @@
           <p:cNvPr id="3" name="next-steps-steps">
             <a:extLst xmlns:a="http://schemas.openxmlformats.org/drawingml/2006/main">
               <a:ext uri="{FF2B5EF4-FFF2-40B4-BE49-F238E27FC236}">
-                <a16:creationId xmlns:a16="http://schemas.microsoft.com/office/drawing/2014/main" id="{36C77483-AAAC-4338-9832-48AF316CB5BE}"/>
+                <a16:creationId xmlns:a16="http://schemas.microsoft.com/office/drawing/2014/main" id="{52C2BE61-EF0F-4A35-80B3-489A50194421}"/>
               </a:ext>
             </a:extLst>
           </p:cNvPr>
@@ -2320,7 +2320,7 @@
     </p:spTree>
     <p:extLst>
       <p:ext uri="{BB962C8B-B14F-4D97-AF65-F5344CB8AC3E}">
-        <p14:creationId xmlns:p14="http://schemas.microsoft.com/office/powerpoint/2010/main" val="958960915"/>
+        <p14:creationId xmlns:p14="http://schemas.microsoft.com/office/powerpoint/2010/main" val="116973843"/>
       </p:ext>
     </p:extLst>
   </p:cSld>
@@ -2351,7 +2351,7 @@
           <p:cNvPr id="5" name="slide-2-title">
             <a:extLst xmlns:a="http://schemas.openxmlformats.org/drawingml/2006/main">
               <a:ext uri="{FF2B5EF4-FFF2-40B4-BE49-F238E27FC236}">
-                <a16:creationId xmlns:a16="http://schemas.microsoft.com/office/drawing/2014/main" id="{D269B630-07DE-40C4-950F-409A6095EC33}"/>
+                <a16:creationId xmlns:a16="http://schemas.microsoft.com/office/drawing/2014/main" id="{6BB4FC6B-7738-48C1-A7B0-62B9EDE2EE6C}"/>
               </a:ext>
             </a:extLst>
           </p:cNvPr>
@@ -2413,7 +2413,7 @@
           <p:nvPr/>
         </p:nvPicPr>
         <p:blipFill>
-          <a:blip xmlns:r="http://schemas.openxmlformats.org/officeDocument/2006/relationships" xmlns:a="http://schemas.openxmlformats.org/drawingml/2006/main" r:embed="R00152535842c4d9d"/>
+          <a:blip xmlns:r="http://schemas.openxmlformats.org/officeDocument/2006/relationships" xmlns:a="http://schemas.openxmlformats.org/drawingml/2006/main" r:embed="R225ced0e67594870"/>
           <a:stretch xmlns:a="http://schemas.openxmlformats.org/drawingml/2006/main"/>
         </p:blipFill>
         <p:spPr>
@@ -2431,7 +2431,7 @@
           <p:cNvPr id="3" name="problem-claim">
             <a:extLst xmlns:a="http://schemas.openxmlformats.org/drawingml/2006/main">
               <a:ext uri="{FF2B5EF4-FFF2-40B4-BE49-F238E27FC236}">
-                <a16:creationId xmlns:a16="http://schemas.microsoft.com/office/drawing/2014/main" id="{0408414D-62B5-4637-90AB-FA0EC915242B}"/>
+                <a16:creationId xmlns:a16="http://schemas.microsoft.com/office/drawing/2014/main" id="{B1839409-A498-4836-A652-0E6D32628849}"/>
               </a:ext>
             </a:extLst>
           </p:cNvPr>
@@ -2442,8 +2442,8 @@
         </p:nvSpPr>
         <p:spPr>
           <a:xfrm xmlns:a="http://schemas.openxmlformats.org/drawingml/2006/main">
-            <a:off x="495300" y="1257300"/>
-            <a:ext cx="4953000" cy="1143000"/>
+            <a:off x="495300" y="1714500"/>
+            <a:ext cx="5143500" cy="1524000"/>
           </a:xfrm>
           <a:prstGeom xmlns:a="http://schemas.openxmlformats.org/drawingml/2006/main" prst="rect">
             <a:avLst/>
@@ -2456,7 +2456,7 @@
         </p:spPr>
         <p:txBody>
           <a:bodyPr xmlns:a="http://schemas.openxmlformats.org/drawingml/2006/main" anchor="t">
-            <a:normAutofit fontScale="71875"/>
+            <a:normAutofit fontScale="89980"/>
           </a:bodyPr>
           <a:lstStyle xmlns:a="http://schemas.openxmlformats.org/drawingml/2006/main"/>
           <a:p xmlns:a="http://schemas.openxmlformats.org/drawingml/2006/main">
@@ -2489,7 +2489,7 @@
           <p:cNvPr id="4" name="problem-body">
             <a:extLst xmlns:a="http://schemas.openxmlformats.org/drawingml/2006/main">
               <a:ext uri="{FF2B5EF4-FFF2-40B4-BE49-F238E27FC236}">
-                <a16:creationId xmlns:a16="http://schemas.microsoft.com/office/drawing/2014/main" id="{140B89B1-D2F0-4224-83E1-27EED14A05ED}"/>
+                <a16:creationId xmlns:a16="http://schemas.microsoft.com/office/drawing/2014/main" id="{344F7FE4-B5E8-4704-9518-C573276EDC2B}"/>
               </a:ext>
             </a:extLst>
           </p:cNvPr>
@@ -2500,8 +2500,8 @@
         </p:nvSpPr>
         <p:spPr>
           <a:xfrm xmlns:a="http://schemas.openxmlformats.org/drawingml/2006/main">
-            <a:off x="495300" y="2647950"/>
-            <a:ext cx="4953000" cy="3143250"/>
+            <a:off x="495300" y="3429000"/>
+            <a:ext cx="5143500" cy="2362200"/>
           </a:xfrm>
           <a:prstGeom xmlns:a="http://schemas.openxmlformats.org/drawingml/2006/main" prst="rect">
             <a:avLst/>
@@ -2601,7 +2601,7 @@
     </p:spTree>
     <p:extLst>
       <p:ext uri="{BB962C8B-B14F-4D97-AF65-F5344CB8AC3E}">
-        <p14:creationId xmlns:p14="http://schemas.microsoft.com/office/powerpoint/2010/main" val="1491487766"/>
+        <p14:creationId xmlns:p14="http://schemas.microsoft.com/office/powerpoint/2010/main" val="1416752345"/>
       </p:ext>
     </p:extLst>
   </p:cSld>
@@ -2632,7 +2632,7 @@
           <p:cNvPr id="9" name="slide-3-title">
             <a:extLst xmlns:a="http://schemas.openxmlformats.org/drawingml/2006/main">
               <a:ext uri="{FF2B5EF4-FFF2-40B4-BE49-F238E27FC236}">
-                <a16:creationId xmlns:a16="http://schemas.microsoft.com/office/drawing/2014/main" id="{23386884-B77E-4E46-968B-70DF5C2249AC}"/>
+                <a16:creationId xmlns:a16="http://schemas.microsoft.com/office/drawing/2014/main" id="{CE7A929C-B3CB-4344-8F72-F2216BD296C0}"/>
               </a:ext>
             </a:extLst>
           </p:cNvPr>
@@ -2690,7 +2690,7 @@
           <p:cNvPr id="2" name="protocol-metric-1">
             <a:extLst xmlns:a="http://schemas.openxmlformats.org/drawingml/2006/main">
               <a:ext uri="{FF2B5EF4-FFF2-40B4-BE49-F238E27FC236}">
-                <a16:creationId xmlns:a16="http://schemas.microsoft.com/office/drawing/2014/main" id="{6310744F-8D82-4142-B2EE-4DE307851F2D}"/>
+                <a16:creationId xmlns:a16="http://schemas.microsoft.com/office/drawing/2014/main" id="{DEB9CC86-115B-44A5-A1B3-EAE30CE73C29}"/>
               </a:ext>
             </a:extLst>
           </p:cNvPr>
@@ -2748,7 +2748,7 @@
           <p:cNvPr id="3" name="protocol-metric-label-1">
             <a:extLst xmlns:a="http://schemas.openxmlformats.org/drawingml/2006/main">
               <a:ext uri="{FF2B5EF4-FFF2-40B4-BE49-F238E27FC236}">
-                <a16:creationId xmlns:a16="http://schemas.microsoft.com/office/drawing/2014/main" id="{AB10E830-4C4E-409E-B9A9-DD6E5147C56C}"/>
+                <a16:creationId xmlns:a16="http://schemas.microsoft.com/office/drawing/2014/main" id="{4E80697D-6780-4347-BFD4-42C7B8EAE643}"/>
               </a:ext>
             </a:extLst>
           </p:cNvPr>
@@ -2806,7 +2806,7 @@
           <p:cNvPr id="4" name="protocol-metric-2">
             <a:extLst xmlns:a="http://schemas.openxmlformats.org/drawingml/2006/main">
               <a:ext uri="{FF2B5EF4-FFF2-40B4-BE49-F238E27FC236}">
-                <a16:creationId xmlns:a16="http://schemas.microsoft.com/office/drawing/2014/main" id="{62C26F07-2C1C-4235-82C1-F6257BB4C4F3}"/>
+                <a16:creationId xmlns:a16="http://schemas.microsoft.com/office/drawing/2014/main" id="{94E32AC2-B308-4F17-AD2B-61F5991A3F6E}"/>
               </a:ext>
             </a:extLst>
           </p:cNvPr>
@@ -2864,7 +2864,7 @@
           <p:cNvPr id="5" name="protocol-metric-label-2">
             <a:extLst xmlns:a="http://schemas.openxmlformats.org/drawingml/2006/main">
               <a:ext uri="{FF2B5EF4-FFF2-40B4-BE49-F238E27FC236}">
-                <a16:creationId xmlns:a16="http://schemas.microsoft.com/office/drawing/2014/main" id="{802D6369-AF05-4361-946A-19FF929471A7}"/>
+                <a16:creationId xmlns:a16="http://schemas.microsoft.com/office/drawing/2014/main" id="{3E6FD1E7-7CBE-4291-B98B-AEAF6C308CED}"/>
               </a:ext>
             </a:extLst>
           </p:cNvPr>
@@ -2922,7 +2922,7 @@
           <p:cNvPr id="6" name="protocol-metric-3">
             <a:extLst xmlns:a="http://schemas.openxmlformats.org/drawingml/2006/main">
               <a:ext uri="{FF2B5EF4-FFF2-40B4-BE49-F238E27FC236}">
-                <a16:creationId xmlns:a16="http://schemas.microsoft.com/office/drawing/2014/main" id="{4D9B44CA-8D37-412A-8172-3D3EF34BF1A4}"/>
+                <a16:creationId xmlns:a16="http://schemas.microsoft.com/office/drawing/2014/main" id="{12CCFD65-E98D-4845-B0DF-1FCFD2B44597}"/>
               </a:ext>
             </a:extLst>
           </p:cNvPr>
@@ -2980,7 +2980,7 @@
           <p:cNvPr id="7" name="protocol-metric-label-3">
             <a:extLst xmlns:a="http://schemas.openxmlformats.org/drawingml/2006/main">
               <a:ext uri="{FF2B5EF4-FFF2-40B4-BE49-F238E27FC236}">
-                <a16:creationId xmlns:a16="http://schemas.microsoft.com/office/drawing/2014/main" id="{ABFE679F-CD67-4F7A-AD7E-846583A6FE99}"/>
+                <a16:creationId xmlns:a16="http://schemas.microsoft.com/office/drawing/2014/main" id="{566296C9-3405-4CD9-8E45-404A9216148E}"/>
               </a:ext>
             </a:extLst>
           </p:cNvPr>
@@ -3038,7 +3038,7 @@
           <p:cNvPr id="8" name="protocol-interpretation">
             <a:extLst xmlns:a="http://schemas.openxmlformats.org/drawingml/2006/main">
               <a:ext uri="{FF2B5EF4-FFF2-40B4-BE49-F238E27FC236}">
-                <a16:creationId xmlns:a16="http://schemas.microsoft.com/office/drawing/2014/main" id="{DAE1F16D-2E5B-43B8-A0C6-51739F38DB8F}"/>
+                <a16:creationId xmlns:a16="http://schemas.microsoft.com/office/drawing/2014/main" id="{EDA987EC-0444-4BB3-ABD2-FD5451045E5C}"/>
               </a:ext>
             </a:extLst>
           </p:cNvPr>
@@ -3094,7 +3094,7 @@
     </p:spTree>
     <p:extLst>
       <p:ext uri="{BB962C8B-B14F-4D97-AF65-F5344CB8AC3E}">
-        <p14:creationId xmlns:p14="http://schemas.microsoft.com/office/powerpoint/2010/main" val="875649331"/>
+        <p14:creationId xmlns:p14="http://schemas.microsoft.com/office/powerpoint/2010/main" val="1595836993"/>
       </p:ext>
     </p:extLst>
   </p:cSld>
@@ -3125,7 +3125,7 @@
           <p:cNvPr id="5" name="slide-4-title">
             <a:extLst xmlns:a="http://schemas.openxmlformats.org/drawingml/2006/main">
               <a:ext uri="{FF2B5EF4-FFF2-40B4-BE49-F238E27FC236}">
-                <a16:creationId xmlns:a16="http://schemas.microsoft.com/office/drawing/2014/main" id="{268A493B-7CF5-4FC8-A8E1-5D76A34B3C76}"/>
+                <a16:creationId xmlns:a16="http://schemas.microsoft.com/office/drawing/2014/main" id="{4FD1D312-62AD-4D33-A096-366DD70DDE3F}"/>
               </a:ext>
             </a:extLst>
           </p:cNvPr>
@@ -3187,7 +3187,7 @@
           <p:nvPr/>
         </p:nvPicPr>
         <p:blipFill>
-          <a:blip xmlns:r="http://schemas.openxmlformats.org/officeDocument/2006/relationships" xmlns:a="http://schemas.openxmlformats.org/drawingml/2006/main" r:embed="R2f63fcc1cd7d418b"/>
+          <a:blip xmlns:r="http://schemas.openxmlformats.org/officeDocument/2006/relationships" xmlns:a="http://schemas.openxmlformats.org/drawingml/2006/main" r:embed="R2ad33671184d4988"/>
           <a:stretch xmlns:a="http://schemas.openxmlformats.org/drawingml/2006/main"/>
         </p:blipFill>
         <p:spPr>
@@ -3205,7 +3205,7 @@
           <p:cNvPr id="3" name="optimization-claim">
             <a:extLst xmlns:a="http://schemas.openxmlformats.org/drawingml/2006/main">
               <a:ext uri="{FF2B5EF4-FFF2-40B4-BE49-F238E27FC236}">
-                <a16:creationId xmlns:a16="http://schemas.microsoft.com/office/drawing/2014/main" id="{56D53DD5-07D8-499B-87B6-DD794036F012}"/>
+                <a16:creationId xmlns:a16="http://schemas.microsoft.com/office/drawing/2014/main" id="{B43BB884-DEBA-44A2-9871-8714310A2A57}"/>
               </a:ext>
             </a:extLst>
           </p:cNvPr>
@@ -3216,8 +3216,8 @@
         </p:nvSpPr>
         <p:spPr>
           <a:xfrm xmlns:a="http://schemas.openxmlformats.org/drawingml/2006/main">
-            <a:off x="495300" y="1257300"/>
-            <a:ext cx="4953000" cy="1143000"/>
+            <a:off x="495300" y="1714500"/>
+            <a:ext cx="5143500" cy="1524000"/>
           </a:xfrm>
           <a:prstGeom xmlns:a="http://schemas.openxmlformats.org/drawingml/2006/main" prst="rect">
             <a:avLst/>
@@ -3230,7 +3230,7 @@
         </p:spPr>
         <p:txBody>
           <a:bodyPr xmlns:a="http://schemas.openxmlformats.org/drawingml/2006/main" anchor="t">
-            <a:normAutofit fontScale="71875"/>
+            <a:normAutofit fontScale="94592"/>
           </a:bodyPr>
           <a:lstStyle xmlns:a="http://schemas.openxmlformats.org/drawingml/2006/main"/>
           <a:p xmlns:a="http://schemas.openxmlformats.org/drawingml/2006/main">
@@ -3263,7 +3263,7 @@
           <p:cNvPr id="4" name="optimization-body">
             <a:extLst xmlns:a="http://schemas.openxmlformats.org/drawingml/2006/main">
               <a:ext uri="{FF2B5EF4-FFF2-40B4-BE49-F238E27FC236}">
-                <a16:creationId xmlns:a16="http://schemas.microsoft.com/office/drawing/2014/main" id="{E9737406-6FAF-4517-9964-4854C1C42E27}"/>
+                <a16:creationId xmlns:a16="http://schemas.microsoft.com/office/drawing/2014/main" id="{C29BBAA3-559F-4D6F-B304-83613125727D}"/>
               </a:ext>
             </a:extLst>
           </p:cNvPr>
@@ -3274,8 +3274,8 @@
         </p:nvSpPr>
         <p:spPr>
           <a:xfrm xmlns:a="http://schemas.openxmlformats.org/drawingml/2006/main">
-            <a:off x="495300" y="2647950"/>
-            <a:ext cx="4953000" cy="3143250"/>
+            <a:off x="495300" y="3429000"/>
+            <a:ext cx="5143500" cy="2362200"/>
           </a:xfrm>
           <a:prstGeom xmlns:a="http://schemas.openxmlformats.org/drawingml/2006/main" prst="rect">
             <a:avLst/>
@@ -3347,7 +3347,7 @@
     </p:spTree>
     <p:extLst>
       <p:ext uri="{BB962C8B-B14F-4D97-AF65-F5344CB8AC3E}">
-        <p14:creationId xmlns:p14="http://schemas.microsoft.com/office/powerpoint/2010/main" val="1054162339"/>
+        <p14:creationId xmlns:p14="http://schemas.microsoft.com/office/powerpoint/2010/main" val="1450763449"/>
       </p:ext>
     </p:extLst>
   </p:cSld>
@@ -3378,7 +3378,7 @@
           <p:cNvPr id="5" name="slide-5-title">
             <a:extLst xmlns:a="http://schemas.openxmlformats.org/drawingml/2006/main">
               <a:ext uri="{FF2B5EF4-FFF2-40B4-BE49-F238E27FC236}">
-                <a16:creationId xmlns:a16="http://schemas.microsoft.com/office/drawing/2014/main" id="{E37EB823-8A67-4906-B80F-50555C6F2396}"/>
+                <a16:creationId xmlns:a16="http://schemas.microsoft.com/office/drawing/2014/main" id="{2E53F703-C611-4598-ABAB-C9A531827EEC}"/>
               </a:ext>
             </a:extLst>
           </p:cNvPr>
@@ -3440,7 +3440,7 @@
           <p:nvPr/>
         </p:nvPicPr>
         <p:blipFill>
-          <a:blip xmlns:r="http://schemas.openxmlformats.org/officeDocument/2006/relationships" xmlns:a="http://schemas.openxmlformats.org/drawingml/2006/main" r:embed="R6fc64c2bcb6147a7"/>
+          <a:blip xmlns:r="http://schemas.openxmlformats.org/officeDocument/2006/relationships" xmlns:a="http://schemas.openxmlformats.org/drawingml/2006/main" r:embed="R62122c299c2f499c"/>
           <a:stretch xmlns:a="http://schemas.openxmlformats.org/drawingml/2006/main"/>
         </p:blipFill>
         <p:spPr>
@@ -3458,7 +3458,7 @@
           <p:cNvPr id="3" name="deterministic-claim">
             <a:extLst xmlns:a="http://schemas.openxmlformats.org/drawingml/2006/main">
               <a:ext uri="{FF2B5EF4-FFF2-40B4-BE49-F238E27FC236}">
-                <a16:creationId xmlns:a16="http://schemas.microsoft.com/office/drawing/2014/main" id="{7B1873D1-9E60-4EE9-B5E3-24E946ACDBF4}"/>
+                <a16:creationId xmlns:a16="http://schemas.microsoft.com/office/drawing/2014/main" id="{752B321F-A94C-45F7-8C1F-C2CEDCEA3BAC}"/>
               </a:ext>
             </a:extLst>
           </p:cNvPr>
@@ -3469,8 +3469,8 @@
         </p:nvSpPr>
         <p:spPr>
           <a:xfrm xmlns:a="http://schemas.openxmlformats.org/drawingml/2006/main">
-            <a:off x="495300" y="1257300"/>
-            <a:ext cx="4953000" cy="1143000"/>
+            <a:off x="495300" y="1714500"/>
+            <a:ext cx="5143500" cy="1524000"/>
           </a:xfrm>
           <a:prstGeom xmlns:a="http://schemas.openxmlformats.org/drawingml/2006/main" prst="rect">
             <a:avLst/>
@@ -3483,7 +3483,7 @@
         </p:spPr>
         <p:txBody>
           <a:bodyPr xmlns:a="http://schemas.openxmlformats.org/drawingml/2006/main" anchor="t">
-            <a:normAutofit fontScale="95833"/>
+            <a:normAutofit fontScale="100000"/>
           </a:bodyPr>
           <a:lstStyle xmlns:a="http://schemas.openxmlformats.org/drawingml/2006/main"/>
           <a:p xmlns:a="http://schemas.openxmlformats.org/drawingml/2006/main">
@@ -3516,7 +3516,7 @@
           <p:cNvPr id="4" name="deterministic-body">
             <a:extLst xmlns:a="http://schemas.openxmlformats.org/drawingml/2006/main">
               <a:ext uri="{FF2B5EF4-FFF2-40B4-BE49-F238E27FC236}">
-                <a16:creationId xmlns:a16="http://schemas.microsoft.com/office/drawing/2014/main" id="{121FA8C6-D895-4A89-89C6-6DBECE8CBF38}"/>
+                <a16:creationId xmlns:a16="http://schemas.microsoft.com/office/drawing/2014/main" id="{EFE1A3C7-0732-4A41-9015-0F1502229B54}"/>
               </a:ext>
             </a:extLst>
           </p:cNvPr>
@@ -3527,8 +3527,8 @@
         </p:nvSpPr>
         <p:spPr>
           <a:xfrm xmlns:a="http://schemas.openxmlformats.org/drawingml/2006/main">
-            <a:off x="495300" y="2647950"/>
-            <a:ext cx="4953000" cy="3143250"/>
+            <a:off x="495300" y="3429000"/>
+            <a:ext cx="5143500" cy="2362200"/>
           </a:xfrm>
           <a:prstGeom xmlns:a="http://schemas.openxmlformats.org/drawingml/2006/main" prst="rect">
             <a:avLst/>
@@ -3600,7 +3600,7 @@
     </p:spTree>
     <p:extLst>
       <p:ext uri="{BB962C8B-B14F-4D97-AF65-F5344CB8AC3E}">
-        <p14:creationId xmlns:p14="http://schemas.microsoft.com/office/powerpoint/2010/main" val="736190529"/>
+        <p14:creationId xmlns:p14="http://schemas.microsoft.com/office/powerpoint/2010/main" val="38188054"/>
       </p:ext>
     </p:extLst>
   </p:cSld>
@@ -3631,7 +3631,7 @@
           <p:cNvPr id="5" name="slide-6-title">
             <a:extLst xmlns:a="http://schemas.openxmlformats.org/drawingml/2006/main">
               <a:ext uri="{FF2B5EF4-FFF2-40B4-BE49-F238E27FC236}">
-                <a16:creationId xmlns:a16="http://schemas.microsoft.com/office/drawing/2014/main" id="{756E6947-FBA6-475E-8210-100202272BFB}"/>
+                <a16:creationId xmlns:a16="http://schemas.microsoft.com/office/drawing/2014/main" id="{FB7FA2DB-77EE-4E2A-8DA7-37EFAC7750F6}"/>
               </a:ext>
             </a:extLst>
           </p:cNvPr>
@@ -3693,7 +3693,7 @@
           <p:nvPr/>
         </p:nvPicPr>
         <p:blipFill>
-          <a:blip xmlns:r="http://schemas.openxmlformats.org/officeDocument/2006/relationships" xmlns:a="http://schemas.openxmlformats.org/drawingml/2006/main" r:embed="Rd69df4dffede47b8"/>
+          <a:blip xmlns:r="http://schemas.openxmlformats.org/officeDocument/2006/relationships" xmlns:a="http://schemas.openxmlformats.org/drawingml/2006/main" r:embed="R7e1cbd59f5a54b41"/>
           <a:stretch xmlns:a="http://schemas.openxmlformats.org/drawingml/2006/main"/>
         </p:blipFill>
         <p:spPr>
@@ -3711,7 +3711,7 @@
           <p:cNvPr id="3" name="stochastic-claim">
             <a:extLst xmlns:a="http://schemas.openxmlformats.org/drawingml/2006/main">
               <a:ext uri="{FF2B5EF4-FFF2-40B4-BE49-F238E27FC236}">
-                <a16:creationId xmlns:a16="http://schemas.microsoft.com/office/drawing/2014/main" id="{92391F8C-CFFC-4703-A9D1-A4112B9C9D47}"/>
+                <a16:creationId xmlns:a16="http://schemas.microsoft.com/office/drawing/2014/main" id="{F6BA76A3-32EC-46A5-A112-F6A99F36597F}"/>
               </a:ext>
             </a:extLst>
           </p:cNvPr>
@@ -3722,8 +3722,8 @@
         </p:nvSpPr>
         <p:spPr>
           <a:xfrm xmlns:a="http://schemas.openxmlformats.org/drawingml/2006/main">
-            <a:off x="495300" y="1257300"/>
-            <a:ext cx="4953000" cy="1143000"/>
+            <a:off x="495300" y="1714500"/>
+            <a:ext cx="5143500" cy="1524000"/>
           </a:xfrm>
           <a:prstGeom xmlns:a="http://schemas.openxmlformats.org/drawingml/2006/main" prst="rect">
             <a:avLst/>
@@ -3736,7 +3736,7 @@
         </p:spPr>
         <p:txBody>
           <a:bodyPr xmlns:a="http://schemas.openxmlformats.org/drawingml/2006/main" anchor="t">
-            <a:normAutofit fontScale="95833"/>
+            <a:normAutofit fontScale="100000"/>
           </a:bodyPr>
           <a:lstStyle xmlns:a="http://schemas.openxmlformats.org/drawingml/2006/main"/>
           <a:p xmlns:a="http://schemas.openxmlformats.org/drawingml/2006/main">
@@ -3769,7 +3769,7 @@
           <p:cNvPr id="4" name="stochastic-body">
             <a:extLst xmlns:a="http://schemas.openxmlformats.org/drawingml/2006/main">
               <a:ext uri="{FF2B5EF4-FFF2-40B4-BE49-F238E27FC236}">
-                <a16:creationId xmlns:a16="http://schemas.microsoft.com/office/drawing/2014/main" id="{BF2B04B3-82C3-42CA-BFAD-5C645BB0DCA5}"/>
+                <a16:creationId xmlns:a16="http://schemas.microsoft.com/office/drawing/2014/main" id="{D7F2EDD9-A44E-4ED3-8C33-282B292E2650}"/>
               </a:ext>
             </a:extLst>
           </p:cNvPr>
@@ -3780,8 +3780,8 @@
         </p:nvSpPr>
         <p:spPr>
           <a:xfrm xmlns:a="http://schemas.openxmlformats.org/drawingml/2006/main">
-            <a:off x="495300" y="2647950"/>
-            <a:ext cx="4953000" cy="3143250"/>
+            <a:off x="495300" y="3429000"/>
+            <a:ext cx="5143500" cy="2362200"/>
           </a:xfrm>
           <a:prstGeom xmlns:a="http://schemas.openxmlformats.org/drawingml/2006/main" prst="rect">
             <a:avLst/>
@@ -3853,7 +3853,7 @@
     </p:spTree>
     <p:extLst>
       <p:ext uri="{BB962C8B-B14F-4D97-AF65-F5344CB8AC3E}">
-        <p14:creationId xmlns:p14="http://schemas.microsoft.com/office/powerpoint/2010/main" val="1451530630"/>
+        <p14:creationId xmlns:p14="http://schemas.microsoft.com/office/powerpoint/2010/main" val="1367873802"/>
       </p:ext>
     </p:extLst>
   </p:cSld>
@@ -3884,7 +3884,7 @@
           <p:cNvPr id="5" name="slide-7-title">
             <a:extLst xmlns:a="http://schemas.openxmlformats.org/drawingml/2006/main">
               <a:ext uri="{FF2B5EF4-FFF2-40B4-BE49-F238E27FC236}">
-                <a16:creationId xmlns:a16="http://schemas.microsoft.com/office/drawing/2014/main" id="{20D271B1-5324-4C46-80E8-5303043ABFAC}"/>
+                <a16:creationId xmlns:a16="http://schemas.microsoft.com/office/drawing/2014/main" id="{D63E678F-8E54-49B3-85C8-F15C930A769B}"/>
               </a:ext>
             </a:extLst>
           </p:cNvPr>
@@ -3946,7 +3946,7 @@
           <p:nvPr/>
         </p:nvPicPr>
         <p:blipFill>
-          <a:blip xmlns:r="http://schemas.openxmlformats.org/officeDocument/2006/relationships" xmlns:a="http://schemas.openxmlformats.org/drawingml/2006/main" r:embed="R4d33f6f335c74223"/>
+          <a:blip xmlns:r="http://schemas.openxmlformats.org/officeDocument/2006/relationships" xmlns:a="http://schemas.openxmlformats.org/drawingml/2006/main" r:embed="R28826651ec69401d"/>
           <a:stretch xmlns:a="http://schemas.openxmlformats.org/drawingml/2006/main"/>
         </p:blipFill>
         <p:spPr>
@@ -3964,7 +3964,7 @@
           <p:cNvPr id="3" name="cartesian-claim">
             <a:extLst xmlns:a="http://schemas.openxmlformats.org/drawingml/2006/main">
               <a:ext uri="{FF2B5EF4-FFF2-40B4-BE49-F238E27FC236}">
-                <a16:creationId xmlns:a16="http://schemas.microsoft.com/office/drawing/2014/main" id="{F3FBA367-F907-425E-BE92-F383CE4EF92C}"/>
+                <a16:creationId xmlns:a16="http://schemas.microsoft.com/office/drawing/2014/main" id="{741683D3-29E5-446C-A2E3-21771BC4DCED}"/>
               </a:ext>
             </a:extLst>
           </p:cNvPr>
@@ -3975,8 +3975,8 @@
         </p:nvSpPr>
         <p:spPr>
           <a:xfrm xmlns:a="http://schemas.openxmlformats.org/drawingml/2006/main">
-            <a:off x="495300" y="1257300"/>
-            <a:ext cx="4953000" cy="1143000"/>
+            <a:off x="495300" y="1714500"/>
+            <a:ext cx="5143500" cy="1524000"/>
           </a:xfrm>
           <a:prstGeom xmlns:a="http://schemas.openxmlformats.org/drawingml/2006/main" prst="rect">
             <a:avLst/>
@@ -3989,7 +3989,7 @@
         </p:spPr>
         <p:txBody>
           <a:bodyPr xmlns:a="http://schemas.openxmlformats.org/drawingml/2006/main" anchor="t">
-            <a:normAutofit fontScale="71875"/>
+            <a:normAutofit fontScale="91267"/>
           </a:bodyPr>
           <a:lstStyle xmlns:a="http://schemas.openxmlformats.org/drawingml/2006/main"/>
           <a:p xmlns:a="http://schemas.openxmlformats.org/drawingml/2006/main">
@@ -4022,7 +4022,7 @@
           <p:cNvPr id="4" name="cartesian-body">
             <a:extLst xmlns:a="http://schemas.openxmlformats.org/drawingml/2006/main">
               <a:ext uri="{FF2B5EF4-FFF2-40B4-BE49-F238E27FC236}">
-                <a16:creationId xmlns:a16="http://schemas.microsoft.com/office/drawing/2014/main" id="{663E50EA-659E-4729-82EB-F0AD96621282}"/>
+                <a16:creationId xmlns:a16="http://schemas.microsoft.com/office/drawing/2014/main" id="{2A7A8ADF-B25A-4604-8FB0-E3BE4D6C8037}"/>
               </a:ext>
             </a:extLst>
           </p:cNvPr>
@@ -4033,8 +4033,8 @@
         </p:nvSpPr>
         <p:spPr>
           <a:xfrm xmlns:a="http://schemas.openxmlformats.org/drawingml/2006/main">
-            <a:off x="495300" y="2647950"/>
-            <a:ext cx="4953000" cy="3143250"/>
+            <a:off x="495300" y="3429000"/>
+            <a:ext cx="5143500" cy="2362200"/>
           </a:xfrm>
           <a:prstGeom xmlns:a="http://schemas.openxmlformats.org/drawingml/2006/main" prst="rect">
             <a:avLst/>
@@ -4106,7 +4106,7 @@
     </p:spTree>
     <p:extLst>
       <p:ext uri="{BB962C8B-B14F-4D97-AF65-F5344CB8AC3E}">
-        <p14:creationId xmlns:p14="http://schemas.microsoft.com/office/powerpoint/2010/main" val="1042195334"/>
+        <p14:creationId xmlns:p14="http://schemas.microsoft.com/office/powerpoint/2010/main" val="231875004"/>
       </p:ext>
     </p:extLst>
   </p:cSld>
@@ -4137,7 +4137,7 @@
           <p:cNvPr id="9" name="slide-8-title">
             <a:extLst xmlns:a="http://schemas.openxmlformats.org/drawingml/2006/main">
               <a:ext uri="{FF2B5EF4-FFF2-40B4-BE49-F238E27FC236}">
-                <a16:creationId xmlns:a16="http://schemas.microsoft.com/office/drawing/2014/main" id="{2E6246ED-8B3A-4243-9EA8-23ACBF93C859}"/>
+                <a16:creationId xmlns:a16="http://schemas.microsoft.com/office/drawing/2014/main" id="{F981B8D5-5B3D-4AF7-A448-3BAF88440CDE}"/>
               </a:ext>
             </a:extLst>
           </p:cNvPr>
@@ -4195,7 +4195,7 @@
           <p:cNvPr id="2" name="cross-validation-metric-1">
             <a:extLst xmlns:a="http://schemas.openxmlformats.org/drawingml/2006/main">
               <a:ext uri="{FF2B5EF4-FFF2-40B4-BE49-F238E27FC236}">
-                <a16:creationId xmlns:a16="http://schemas.microsoft.com/office/drawing/2014/main" id="{70DBCAD4-908A-49AC-9BC2-850D0729C00A}"/>
+                <a16:creationId xmlns:a16="http://schemas.microsoft.com/office/drawing/2014/main" id="{B5838379-FA3C-4E0D-AE90-4BA6397EC401}"/>
               </a:ext>
             </a:extLst>
           </p:cNvPr>
@@ -4253,7 +4253,7 @@
           <p:cNvPr id="3" name="cross-validation-metric-label-1">
             <a:extLst xmlns:a="http://schemas.openxmlformats.org/drawingml/2006/main">
               <a:ext uri="{FF2B5EF4-FFF2-40B4-BE49-F238E27FC236}">
-                <a16:creationId xmlns:a16="http://schemas.microsoft.com/office/drawing/2014/main" id="{F781F559-28BA-40A0-8DBC-63180DC4D28B}"/>
+                <a16:creationId xmlns:a16="http://schemas.microsoft.com/office/drawing/2014/main" id="{72C2CC2A-6688-49AB-9372-6BB04412F3AE}"/>
               </a:ext>
             </a:extLst>
           </p:cNvPr>
@@ -4311,7 +4311,7 @@
           <p:cNvPr id="4" name="cross-validation-metric-2">
             <a:extLst xmlns:a="http://schemas.openxmlformats.org/drawingml/2006/main">
               <a:ext uri="{FF2B5EF4-FFF2-40B4-BE49-F238E27FC236}">
-                <a16:creationId xmlns:a16="http://schemas.microsoft.com/office/drawing/2014/main" id="{A0FF328C-5CBF-4D2C-996A-027EEF9DCCC9}"/>
+                <a16:creationId xmlns:a16="http://schemas.microsoft.com/office/drawing/2014/main" id="{FDF8650E-1001-4E62-8485-A0758F5B6D38}"/>
               </a:ext>
             </a:extLst>
           </p:cNvPr>
@@ -4369,7 +4369,7 @@
           <p:cNvPr id="5" name="cross-validation-metric-label-2">
             <a:extLst xmlns:a="http://schemas.openxmlformats.org/drawingml/2006/main">
               <a:ext uri="{FF2B5EF4-FFF2-40B4-BE49-F238E27FC236}">
-                <a16:creationId xmlns:a16="http://schemas.microsoft.com/office/drawing/2014/main" id="{D7C3569F-D50C-4836-9D4D-7EFDA9E45A51}"/>
+                <a16:creationId xmlns:a16="http://schemas.microsoft.com/office/drawing/2014/main" id="{E50402F1-A1C3-47D7-9004-71E6DC721B72}"/>
               </a:ext>
             </a:extLst>
           </p:cNvPr>
@@ -4427,7 +4427,7 @@
           <p:cNvPr id="6" name="cross-validation-metric-3">
             <a:extLst xmlns:a="http://schemas.openxmlformats.org/drawingml/2006/main">
               <a:ext uri="{FF2B5EF4-FFF2-40B4-BE49-F238E27FC236}">
-                <a16:creationId xmlns:a16="http://schemas.microsoft.com/office/drawing/2014/main" id="{80B44C06-6D4D-422F-B3A1-C77D9F7467D8}"/>
+                <a16:creationId xmlns:a16="http://schemas.microsoft.com/office/drawing/2014/main" id="{2D59E4E3-EA8E-43DC-B3B6-9D5F20EBA687}"/>
               </a:ext>
             </a:extLst>
           </p:cNvPr>
@@ -4485,7 +4485,7 @@
           <p:cNvPr id="7" name="cross-validation-metric-label-3">
             <a:extLst xmlns:a="http://schemas.openxmlformats.org/drawingml/2006/main">
               <a:ext uri="{FF2B5EF4-FFF2-40B4-BE49-F238E27FC236}">
-                <a16:creationId xmlns:a16="http://schemas.microsoft.com/office/drawing/2014/main" id="{5808237A-505D-48C7-B780-E8C419750B2F}"/>
+                <a16:creationId xmlns:a16="http://schemas.microsoft.com/office/drawing/2014/main" id="{F07DDE4E-74D1-4D0E-B69F-1EBFA19F9118}"/>
               </a:ext>
             </a:extLst>
           </p:cNvPr>
@@ -4543,7 +4543,7 @@
           <p:cNvPr id="8" name="cross-validation-interpretation">
             <a:extLst xmlns:a="http://schemas.openxmlformats.org/drawingml/2006/main">
               <a:ext uri="{FF2B5EF4-FFF2-40B4-BE49-F238E27FC236}">
-                <a16:creationId xmlns:a16="http://schemas.microsoft.com/office/drawing/2014/main" id="{8D956A82-DADF-4DF1-BDA5-8392BD824387}"/>
+                <a16:creationId xmlns:a16="http://schemas.microsoft.com/office/drawing/2014/main" id="{A222B6D0-C44C-40F6-8505-8F6143CA606F}"/>
               </a:ext>
             </a:extLst>
           </p:cNvPr>
@@ -4599,7 +4599,7 @@
     </p:spTree>
     <p:extLst>
       <p:ext uri="{BB962C8B-B14F-4D97-AF65-F5344CB8AC3E}">
-        <p14:creationId xmlns:p14="http://schemas.microsoft.com/office/powerpoint/2010/main" val="422895843"/>
+        <p14:creationId xmlns:p14="http://schemas.microsoft.com/office/powerpoint/2010/main" val="1527312909"/>
       </p:ext>
     </p:extLst>
   </p:cSld>
@@ -4630,7 +4630,7 @@
           <p:cNvPr id="9" name="slide-9-title">
             <a:extLst xmlns:a="http://schemas.openxmlformats.org/drawingml/2006/main">
               <a:ext uri="{FF2B5EF4-FFF2-40B4-BE49-F238E27FC236}">
-                <a16:creationId xmlns:a16="http://schemas.microsoft.com/office/drawing/2014/main" id="{1005A00B-A0E7-454D-9FF1-4DAFAAAD6841}"/>
+                <a16:creationId xmlns:a16="http://schemas.microsoft.com/office/drawing/2014/main" id="{C1F1E7D4-6D24-4B1F-969A-C0E2E3D744B0}"/>
               </a:ext>
             </a:extLst>
           </p:cNvPr>
@@ -4641,8 +4641,8 @@
         </p:nvSpPr>
         <p:spPr>
           <a:xfrm xmlns:a="http://schemas.openxmlformats.org/drawingml/2006/main">
-            <a:off x="495300" y="323850"/>
-            <a:ext cx="11125200" cy="685800"/>
+            <a:off x="495300" y="228600"/>
+            <a:ext cx="11125200" cy="1066800"/>
           </a:xfrm>
           <a:prstGeom xmlns:a="http://schemas.openxmlformats.org/drawingml/2006/main" prst="rect">
             <a:avLst/>
@@ -4655,12 +4655,12 @@
         </p:spPr>
         <p:txBody>
           <a:bodyPr xmlns:a="http://schemas.openxmlformats.org/drawingml/2006/main">
-            <a:normAutofit fontScale="61099"/>
+            <a:normAutofit fontScale="100000"/>
           </a:bodyPr>
           <a:lstStyle xmlns:a="http://schemas.openxmlformats.org/drawingml/2006/main"/>
           <a:p xmlns:a="http://schemas.openxmlformats.org/drawingml/2006/main">
             <a:pPr>
-              <a:defRPr sz="3600" b="1">
+              <a:defRPr sz="2700" b="1">
                 <a:solidFill>
                   <a:srgbClr val="000000"/>
                 </a:solidFill>
@@ -4670,7 +4670,7 @@
               </a:defRPr>
             </a:pPr>
             <a:r>
-              <a:rPr sz="3600" b="1">
+              <a:rPr sz="2700" b="1">
                 <a:solidFill>
                   <a:srgbClr val="000000"/>
                 </a:solidFill>
@@ -4678,7 +4678,30 @@
                 <a:ea typeface="Arial"/>
                 <a:cs typeface="Arial"/>
               </a:rPr>
-              <a:t>There is no universal winner, but optimized PID is the strongest reliability baseline</a:t>
+              <a:t>There is no universal winner, but</a:t>
+            </a:r>
+          </a:p>
+          <a:p xmlns:a="http://schemas.openxmlformats.org/drawingml/2006/main">
+            <a:pPr>
+              <a:defRPr sz="2700" b="1">
+                <a:solidFill>
+                  <a:srgbClr val="000000"/>
+                </a:solidFill>
+                <a:latin typeface="Arial"/>
+                <a:ea typeface="Arial"/>
+                <a:cs typeface="Arial"/>
+              </a:defRPr>
+            </a:pPr>
+            <a:r>
+              <a:rPr sz="2700" b="1">
+                <a:solidFill>
+                  <a:srgbClr val="000000"/>
+                </a:solidFill>
+                <a:latin typeface="Arial"/>
+                <a:ea typeface="Arial"/>
+                <a:cs typeface="Arial"/>
+              </a:rPr>
+              <a:t>optimized PID is the strongest reliability baseline</a:t>
             </a:r>
           </a:p>
         </p:txBody>
@@ -4688,7 +4711,7 @@
           <p:cNvPr id="2" name="conclusion-metric-1">
             <a:extLst xmlns:a="http://schemas.openxmlformats.org/drawingml/2006/main">
               <a:ext uri="{FF2B5EF4-FFF2-40B4-BE49-F238E27FC236}">
-                <a16:creationId xmlns:a16="http://schemas.microsoft.com/office/drawing/2014/main" id="{F55372D3-1894-4850-9C95-CB444369CCE3}"/>
+                <a16:creationId xmlns:a16="http://schemas.microsoft.com/office/drawing/2014/main" id="{6CEEAD44-64E3-4FF8-A400-3DDC82411AE6}"/>
               </a:ext>
             </a:extLst>
           </p:cNvPr>
@@ -4746,7 +4769,7 @@
           <p:cNvPr id="3" name="conclusion-metric-label-1">
             <a:extLst xmlns:a="http://schemas.openxmlformats.org/drawingml/2006/main">
               <a:ext uri="{FF2B5EF4-FFF2-40B4-BE49-F238E27FC236}">
-                <a16:creationId xmlns:a16="http://schemas.microsoft.com/office/drawing/2014/main" id="{80693880-D21E-4160-A7EC-65C246BD2A3B}"/>
+                <a16:creationId xmlns:a16="http://schemas.microsoft.com/office/drawing/2014/main" id="{8D5FD1E3-101D-4B8D-BEE8-9F9EEE65BB57}"/>
               </a:ext>
             </a:extLst>
           </p:cNvPr>
@@ -4804,7 +4827,7 @@
           <p:cNvPr id="4" name="conclusion-metric-2">
             <a:extLst xmlns:a="http://schemas.openxmlformats.org/drawingml/2006/main">
               <a:ext uri="{FF2B5EF4-FFF2-40B4-BE49-F238E27FC236}">
-                <a16:creationId xmlns:a16="http://schemas.microsoft.com/office/drawing/2014/main" id="{D6B188B3-5D0E-4C78-AAEA-26A5B510C0E0}"/>
+                <a16:creationId xmlns:a16="http://schemas.microsoft.com/office/drawing/2014/main" id="{E02E124D-AFCD-441A-A6CE-AC214A2B7764}"/>
               </a:ext>
             </a:extLst>
           </p:cNvPr>
@@ -4862,7 +4885,7 @@
           <p:cNvPr id="5" name="conclusion-metric-label-2">
             <a:extLst xmlns:a="http://schemas.openxmlformats.org/drawingml/2006/main">
               <a:ext uri="{FF2B5EF4-FFF2-40B4-BE49-F238E27FC236}">
-                <a16:creationId xmlns:a16="http://schemas.microsoft.com/office/drawing/2014/main" id="{31AF8383-3012-4D82-97CD-179644110162}"/>
+                <a16:creationId xmlns:a16="http://schemas.microsoft.com/office/drawing/2014/main" id="{DC90107B-E9B7-4B57-90F4-02A960D250FD}"/>
               </a:ext>
             </a:extLst>
           </p:cNvPr>
@@ -4920,7 +4943,7 @@
           <p:cNvPr id="6" name="conclusion-metric-3">
             <a:extLst xmlns:a="http://schemas.openxmlformats.org/drawingml/2006/main">
               <a:ext uri="{FF2B5EF4-FFF2-40B4-BE49-F238E27FC236}">
-                <a16:creationId xmlns:a16="http://schemas.microsoft.com/office/drawing/2014/main" id="{26E717C8-D45C-4AB6-A2A3-699C7E7C0642}"/>
+                <a16:creationId xmlns:a16="http://schemas.microsoft.com/office/drawing/2014/main" id="{D46B9DDA-26CE-40F1-AFBD-71139B8E6E8E}"/>
               </a:ext>
             </a:extLst>
           </p:cNvPr>
@@ -4978,7 +5001,7 @@
           <p:cNvPr id="7" name="conclusion-metric-label-3">
             <a:extLst xmlns:a="http://schemas.openxmlformats.org/drawingml/2006/main">
               <a:ext uri="{FF2B5EF4-FFF2-40B4-BE49-F238E27FC236}">
-                <a16:creationId xmlns:a16="http://schemas.microsoft.com/office/drawing/2014/main" id="{09792F1D-7056-475B-A03C-75211BBA5571}"/>
+                <a16:creationId xmlns:a16="http://schemas.microsoft.com/office/drawing/2014/main" id="{56612BB8-C529-4DF6-BB94-F2C209C48995}"/>
               </a:ext>
             </a:extLst>
           </p:cNvPr>
@@ -5036,7 +5059,7 @@
           <p:cNvPr id="8" name="conclusion-interpretation">
             <a:extLst xmlns:a="http://schemas.openxmlformats.org/drawingml/2006/main">
               <a:ext uri="{FF2B5EF4-FFF2-40B4-BE49-F238E27FC236}">
-                <a16:creationId xmlns:a16="http://schemas.microsoft.com/office/drawing/2014/main" id="{B32DB114-B6B9-491A-ACDD-965AF50CC4EB}"/>
+                <a16:creationId xmlns:a16="http://schemas.microsoft.com/office/drawing/2014/main" id="{A9F21930-B7D2-4100-B64F-30D2DF21E9DC}"/>
               </a:ext>
             </a:extLst>
           </p:cNvPr>
@@ -5092,7 +5115,7 @@
     </p:spTree>
     <p:extLst>
       <p:ext uri="{BB962C8B-B14F-4D97-AF65-F5344CB8AC3E}">
-        <p14:creationId xmlns:p14="http://schemas.microsoft.com/office/powerpoint/2010/main" val="704166685"/>
+        <p14:creationId xmlns:p14="http://schemas.microsoft.com/office/powerpoint/2010/main" val="1411863813"/>
       </p:ext>
     </p:extLst>
   </p:cSld>

</xml_diff>

<commit_message>
test: verify reproducible Phase 7B deliverables
</commit_message>
<xml_diff>
--- a/presentation/final_presentation.pptx
+++ b/presentation/final_presentation.pptx
@@ -2,22 +2,22 @@
 <file path=ppt/presentation.xml><?xml version="1.0" encoding="utf-8"?>
 <p:presentation xmlns:p="http://schemas.openxmlformats.org/presentationml/2006/main">
   <p:sldMasterIdLst>
-    <p:sldMasterId xmlns:r="http://schemas.openxmlformats.org/officeDocument/2006/relationships" id="2147483648" r:id="Ra0deef59aef642df"/>
+    <p:sldMasterId xmlns:r="http://schemas.openxmlformats.org/officeDocument/2006/relationships" id="2147483648" r:id="rId2"/>
   </p:sldMasterIdLst>
   <p:notesMasterIdLst>
-    <p:notesMasterId xmlns:r="http://schemas.openxmlformats.org/officeDocument/2006/relationships" r:id="Rd50b4e1a4ab34741"/>
+    <p:notesMasterId xmlns:r="http://schemas.openxmlformats.org/officeDocument/2006/relationships" r:id="rId3"/>
   </p:notesMasterIdLst>
   <p:sldIdLst>
-    <p:sldId xmlns:r="http://schemas.openxmlformats.org/officeDocument/2006/relationships" id="256" r:id="Rabe40c63e3184f96"/>
-    <p:sldId xmlns:r="http://schemas.openxmlformats.org/officeDocument/2006/relationships" id="257" r:id="R6ae6b776166a4999"/>
-    <p:sldId xmlns:r="http://schemas.openxmlformats.org/officeDocument/2006/relationships" id="258" r:id="R1067689edaac4dd2"/>
-    <p:sldId xmlns:r="http://schemas.openxmlformats.org/officeDocument/2006/relationships" id="259" r:id="R0baaca2a01144859"/>
-    <p:sldId xmlns:r="http://schemas.openxmlformats.org/officeDocument/2006/relationships" id="260" r:id="R547b818add27423b"/>
-    <p:sldId xmlns:r="http://schemas.openxmlformats.org/officeDocument/2006/relationships" id="261" r:id="R024574547ffd4058"/>
-    <p:sldId xmlns:r="http://schemas.openxmlformats.org/officeDocument/2006/relationships" id="262" r:id="R6dd6b0890c3e46b1"/>
-    <p:sldId xmlns:r="http://schemas.openxmlformats.org/officeDocument/2006/relationships" id="263" r:id="R0c4be0b8571b496b"/>
-    <p:sldId xmlns:r="http://schemas.openxmlformats.org/officeDocument/2006/relationships" id="264" r:id="R4580430688594fd0"/>
-    <p:sldId xmlns:r="http://schemas.openxmlformats.org/officeDocument/2006/relationships" id="265" r:id="R0535fd93e93d472d"/>
+    <p:sldId xmlns:r="http://schemas.openxmlformats.org/officeDocument/2006/relationships" id="256" r:id="rId6"/>
+    <p:sldId xmlns:r="http://schemas.openxmlformats.org/officeDocument/2006/relationships" id="257" r:id="rId7"/>
+    <p:sldId xmlns:r="http://schemas.openxmlformats.org/officeDocument/2006/relationships" id="258" r:id="rId8"/>
+    <p:sldId xmlns:r="http://schemas.openxmlformats.org/officeDocument/2006/relationships" id="259" r:id="rId9"/>
+    <p:sldId xmlns:r="http://schemas.openxmlformats.org/officeDocument/2006/relationships" id="260" r:id="rId10"/>
+    <p:sldId xmlns:r="http://schemas.openxmlformats.org/officeDocument/2006/relationships" id="261" r:id="rId11"/>
+    <p:sldId xmlns:r="http://schemas.openxmlformats.org/officeDocument/2006/relationships" id="262" r:id="rId12"/>
+    <p:sldId xmlns:r="http://schemas.openxmlformats.org/officeDocument/2006/relationships" id="263" r:id="rId13"/>
+    <p:sldId xmlns:r="http://schemas.openxmlformats.org/officeDocument/2006/relationships" id="264" r:id="rId14"/>
+    <p:sldId xmlns:r="http://schemas.openxmlformats.org/officeDocument/2006/relationships" id="265" r:id="rId15"/>
   </p:sldIdLst>
   <p:sldSz cx="12192000" cy="6858000"/>
   <p:notesSz cx="6858000" cy="9144000"/>
@@ -1374,7 +1374,7 @@
   </p:cSld>
   <p:clrMap bg1="lt1" tx1="dk1" bg2="lt2" tx2="dk2" accent1="accent1" accent2="accent2" accent3="accent3" accent4="accent4" accent5="accent5" accent6="accent6" hlink="hlink" folHlink="folHlink"/>
   <p:sldLayoutIdLst>
-    <p:sldLayoutId xmlns:r="http://schemas.openxmlformats.org/officeDocument/2006/relationships" id="2147483649" r:id="R927f68adeef64656"/>
+    <p:sldLayoutId xmlns:r="http://schemas.openxmlformats.org/officeDocument/2006/relationships" id="2147483649" r:id="rId2"/>
   </p:sldLayoutIdLst>
   <p:txStyles>
     <p:titleStyle>
@@ -1929,7 +1929,7 @@
           <p:nvPr/>
         </p:nvPicPr>
         <p:blipFill>
-          <a:blip xmlns:r="http://schemas.openxmlformats.org/officeDocument/2006/relationships" xmlns:a="http://schemas.openxmlformats.org/drawingml/2006/main" r:embed="R0fd6e0a7140e4fa3"/>
+          <a:blip xmlns:r="http://schemas.openxmlformats.org/officeDocument/2006/relationships" xmlns:a="http://schemas.openxmlformats.org/drawingml/2006/main" r:embed="rId2"/>
           <a:stretch xmlns:a="http://schemas.openxmlformats.org/drawingml/2006/main"/>
         </p:blipFill>
         <p:spPr>
@@ -1947,7 +1947,7 @@
           <p:cNvPr id="2" name="cover-title">
             <a:extLst xmlns:a="http://schemas.openxmlformats.org/drawingml/2006/main">
               <a:ext uri="{FF2B5EF4-FFF2-40B4-BE49-F238E27FC236}">
-                <a16:creationId xmlns:a16="http://schemas.microsoft.com/office/drawing/2014/main" id="{E49DCBFA-49D5-428C-B554-6F3D9673F2F0}"/>
+                <a16:creationId xmlns:a16="http://schemas.microsoft.com/office/drawing/2014/main" id="{00000000-0000-0000-0000-000000000001}"/>
               </a:ext>
             </a:extLst>
           </p:cNvPr>
@@ -2005,7 +2005,7 @@
           <p:cNvPr id="3" name="cover-subtitle">
             <a:extLst xmlns:a="http://schemas.openxmlformats.org/drawingml/2006/main">
               <a:ext uri="{FF2B5EF4-FFF2-40B4-BE49-F238E27FC236}">
-                <a16:creationId xmlns:a16="http://schemas.microsoft.com/office/drawing/2014/main" id="{23D8E7CA-5125-4A5E-986D-806D0F62128B}"/>
+                <a16:creationId xmlns:a16="http://schemas.microsoft.com/office/drawing/2014/main" id="{00000000-0000-0000-0000-000000000002}"/>
               </a:ext>
             </a:extLst>
           </p:cNvPr>
@@ -2061,7 +2061,7 @@
     </p:spTree>
     <p:extLst>
       <p:ext uri="{BB962C8B-B14F-4D97-AF65-F5344CB8AC3E}">
-        <p14:creationId xmlns:p14="http://schemas.microsoft.com/office/powerpoint/2010/main" val="710372222"/>
+        <p14:creationId xmlns:p14="http://schemas.microsoft.com/office/powerpoint/2010/main" val="3"/>
       </p:ext>
     </p:extLst>
   </p:cSld>
@@ -2092,7 +2092,7 @@
           <p:cNvPr id="4" name="slide-10-title">
             <a:extLst xmlns:a="http://schemas.openxmlformats.org/drawingml/2006/main">
               <a:ext uri="{FF2B5EF4-FFF2-40B4-BE49-F238E27FC236}">
-                <a16:creationId xmlns:a16="http://schemas.microsoft.com/office/drawing/2014/main" id="{1B79B5AC-8500-4FE8-B7A6-EE614643CF1E}"/>
+                <a16:creationId xmlns:a16="http://schemas.microsoft.com/office/drawing/2014/main" id="{00000000-0000-0000-0000-000000000004}"/>
               </a:ext>
             </a:extLst>
           </p:cNvPr>
@@ -2150,7 +2150,7 @@
           <p:cNvPr id="2" name="next-steps-lead">
             <a:extLst xmlns:a="http://schemas.openxmlformats.org/drawingml/2006/main">
               <a:ext uri="{FF2B5EF4-FFF2-40B4-BE49-F238E27FC236}">
-                <a16:creationId xmlns:a16="http://schemas.microsoft.com/office/drawing/2014/main" id="{F91ECE79-5483-409A-8128-253686870520}"/>
+                <a16:creationId xmlns:a16="http://schemas.microsoft.com/office/drawing/2014/main" id="{00000000-0000-0000-0000-000000000005}"/>
               </a:ext>
             </a:extLst>
           </p:cNvPr>
@@ -2208,7 +2208,7 @@
           <p:cNvPr id="3" name="next-steps-steps">
             <a:extLst xmlns:a="http://schemas.openxmlformats.org/drawingml/2006/main">
               <a:ext uri="{FF2B5EF4-FFF2-40B4-BE49-F238E27FC236}">
-                <a16:creationId xmlns:a16="http://schemas.microsoft.com/office/drawing/2014/main" id="{52C2BE61-EF0F-4A35-80B3-489A50194421}"/>
+                <a16:creationId xmlns:a16="http://schemas.microsoft.com/office/drawing/2014/main" id="{00000000-0000-0000-0000-000000000006}"/>
               </a:ext>
             </a:extLst>
           </p:cNvPr>
@@ -2320,7 +2320,7 @@
     </p:spTree>
     <p:extLst>
       <p:ext uri="{BB962C8B-B14F-4D97-AF65-F5344CB8AC3E}">
-        <p14:creationId xmlns:p14="http://schemas.microsoft.com/office/powerpoint/2010/main" val="116973843"/>
+        <p14:creationId xmlns:p14="http://schemas.microsoft.com/office/powerpoint/2010/main" val="7"/>
       </p:ext>
     </p:extLst>
   </p:cSld>
@@ -2351,7 +2351,7 @@
           <p:cNvPr id="5" name="slide-2-title">
             <a:extLst xmlns:a="http://schemas.openxmlformats.org/drawingml/2006/main">
               <a:ext uri="{FF2B5EF4-FFF2-40B4-BE49-F238E27FC236}">
-                <a16:creationId xmlns:a16="http://schemas.microsoft.com/office/drawing/2014/main" id="{6BB4FC6B-7738-48C1-A7B0-62B9EDE2EE6C}"/>
+                <a16:creationId xmlns:a16="http://schemas.microsoft.com/office/drawing/2014/main" id="{00000000-0000-0000-0000-000000000008}"/>
               </a:ext>
             </a:extLst>
           </p:cNvPr>
@@ -2413,7 +2413,7 @@
           <p:nvPr/>
         </p:nvPicPr>
         <p:blipFill>
-          <a:blip xmlns:r="http://schemas.openxmlformats.org/officeDocument/2006/relationships" xmlns:a="http://schemas.openxmlformats.org/drawingml/2006/main" r:embed="R225ced0e67594870"/>
+          <a:blip xmlns:r="http://schemas.openxmlformats.org/officeDocument/2006/relationships" xmlns:a="http://schemas.openxmlformats.org/drawingml/2006/main" r:embed="rId2"/>
           <a:stretch xmlns:a="http://schemas.openxmlformats.org/drawingml/2006/main"/>
         </p:blipFill>
         <p:spPr>
@@ -2431,7 +2431,7 @@
           <p:cNvPr id="3" name="problem-claim">
             <a:extLst xmlns:a="http://schemas.openxmlformats.org/drawingml/2006/main">
               <a:ext uri="{FF2B5EF4-FFF2-40B4-BE49-F238E27FC236}">
-                <a16:creationId xmlns:a16="http://schemas.microsoft.com/office/drawing/2014/main" id="{B1839409-A498-4836-A652-0E6D32628849}"/>
+                <a16:creationId xmlns:a16="http://schemas.microsoft.com/office/drawing/2014/main" id="{00000000-0000-0000-0000-000000000009}"/>
               </a:ext>
             </a:extLst>
           </p:cNvPr>
@@ -2489,7 +2489,7 @@
           <p:cNvPr id="4" name="problem-body">
             <a:extLst xmlns:a="http://schemas.openxmlformats.org/drawingml/2006/main">
               <a:ext uri="{FF2B5EF4-FFF2-40B4-BE49-F238E27FC236}">
-                <a16:creationId xmlns:a16="http://schemas.microsoft.com/office/drawing/2014/main" id="{344F7FE4-B5E8-4704-9518-C573276EDC2B}"/>
+                <a16:creationId xmlns:a16="http://schemas.microsoft.com/office/drawing/2014/main" id="{00000000-0000-0000-0000-000000000010}"/>
               </a:ext>
             </a:extLst>
           </p:cNvPr>
@@ -2601,7 +2601,7 @@
     </p:spTree>
     <p:extLst>
       <p:ext uri="{BB962C8B-B14F-4D97-AF65-F5344CB8AC3E}">
-        <p14:creationId xmlns:p14="http://schemas.microsoft.com/office/powerpoint/2010/main" val="1416752345"/>
+        <p14:creationId xmlns:p14="http://schemas.microsoft.com/office/powerpoint/2010/main" val="11"/>
       </p:ext>
     </p:extLst>
   </p:cSld>
@@ -2632,7 +2632,7 @@
           <p:cNvPr id="9" name="slide-3-title">
             <a:extLst xmlns:a="http://schemas.openxmlformats.org/drawingml/2006/main">
               <a:ext uri="{FF2B5EF4-FFF2-40B4-BE49-F238E27FC236}">
-                <a16:creationId xmlns:a16="http://schemas.microsoft.com/office/drawing/2014/main" id="{CE7A929C-B3CB-4344-8F72-F2216BD296C0}"/>
+                <a16:creationId xmlns:a16="http://schemas.microsoft.com/office/drawing/2014/main" id="{00000000-0000-0000-0000-000000000012}"/>
               </a:ext>
             </a:extLst>
           </p:cNvPr>
@@ -2690,7 +2690,7 @@
           <p:cNvPr id="2" name="protocol-metric-1">
             <a:extLst xmlns:a="http://schemas.openxmlformats.org/drawingml/2006/main">
               <a:ext uri="{FF2B5EF4-FFF2-40B4-BE49-F238E27FC236}">
-                <a16:creationId xmlns:a16="http://schemas.microsoft.com/office/drawing/2014/main" id="{DEB9CC86-115B-44A5-A1B3-EAE30CE73C29}"/>
+                <a16:creationId xmlns:a16="http://schemas.microsoft.com/office/drawing/2014/main" id="{00000000-0000-0000-0000-000000000013}"/>
               </a:ext>
             </a:extLst>
           </p:cNvPr>
@@ -2748,7 +2748,7 @@
           <p:cNvPr id="3" name="protocol-metric-label-1">
             <a:extLst xmlns:a="http://schemas.openxmlformats.org/drawingml/2006/main">
               <a:ext uri="{FF2B5EF4-FFF2-40B4-BE49-F238E27FC236}">
-                <a16:creationId xmlns:a16="http://schemas.microsoft.com/office/drawing/2014/main" id="{4E80697D-6780-4347-BFD4-42C7B8EAE643}"/>
+                <a16:creationId xmlns:a16="http://schemas.microsoft.com/office/drawing/2014/main" id="{00000000-0000-0000-0000-000000000014}"/>
               </a:ext>
             </a:extLst>
           </p:cNvPr>
@@ -2806,7 +2806,7 @@
           <p:cNvPr id="4" name="protocol-metric-2">
             <a:extLst xmlns:a="http://schemas.openxmlformats.org/drawingml/2006/main">
               <a:ext uri="{FF2B5EF4-FFF2-40B4-BE49-F238E27FC236}">
-                <a16:creationId xmlns:a16="http://schemas.microsoft.com/office/drawing/2014/main" id="{94E32AC2-B308-4F17-AD2B-61F5991A3F6E}"/>
+                <a16:creationId xmlns:a16="http://schemas.microsoft.com/office/drawing/2014/main" id="{00000000-0000-0000-0000-000000000015}"/>
               </a:ext>
             </a:extLst>
           </p:cNvPr>
@@ -2864,7 +2864,7 @@
           <p:cNvPr id="5" name="protocol-metric-label-2">
             <a:extLst xmlns:a="http://schemas.openxmlformats.org/drawingml/2006/main">
               <a:ext uri="{FF2B5EF4-FFF2-40B4-BE49-F238E27FC236}">
-                <a16:creationId xmlns:a16="http://schemas.microsoft.com/office/drawing/2014/main" id="{3E6FD1E7-7CBE-4291-B98B-AEAF6C308CED}"/>
+                <a16:creationId xmlns:a16="http://schemas.microsoft.com/office/drawing/2014/main" id="{00000000-0000-0000-0000-000000000016}"/>
               </a:ext>
             </a:extLst>
           </p:cNvPr>
@@ -2922,7 +2922,7 @@
           <p:cNvPr id="6" name="protocol-metric-3">
             <a:extLst xmlns:a="http://schemas.openxmlformats.org/drawingml/2006/main">
               <a:ext uri="{FF2B5EF4-FFF2-40B4-BE49-F238E27FC236}">
-                <a16:creationId xmlns:a16="http://schemas.microsoft.com/office/drawing/2014/main" id="{12CCFD65-E98D-4845-B0DF-1FCFD2B44597}"/>
+                <a16:creationId xmlns:a16="http://schemas.microsoft.com/office/drawing/2014/main" id="{00000000-0000-0000-0000-000000000017}"/>
               </a:ext>
             </a:extLst>
           </p:cNvPr>
@@ -2980,7 +2980,7 @@
           <p:cNvPr id="7" name="protocol-metric-label-3">
             <a:extLst xmlns:a="http://schemas.openxmlformats.org/drawingml/2006/main">
               <a:ext uri="{FF2B5EF4-FFF2-40B4-BE49-F238E27FC236}">
-                <a16:creationId xmlns:a16="http://schemas.microsoft.com/office/drawing/2014/main" id="{566296C9-3405-4CD9-8E45-404A9216148E}"/>
+                <a16:creationId xmlns:a16="http://schemas.microsoft.com/office/drawing/2014/main" id="{00000000-0000-0000-0000-000000000018}"/>
               </a:ext>
             </a:extLst>
           </p:cNvPr>
@@ -3038,7 +3038,7 @@
           <p:cNvPr id="8" name="protocol-interpretation">
             <a:extLst xmlns:a="http://schemas.openxmlformats.org/drawingml/2006/main">
               <a:ext uri="{FF2B5EF4-FFF2-40B4-BE49-F238E27FC236}">
-                <a16:creationId xmlns:a16="http://schemas.microsoft.com/office/drawing/2014/main" id="{EDA987EC-0444-4BB3-ABD2-FD5451045E5C}"/>
+                <a16:creationId xmlns:a16="http://schemas.microsoft.com/office/drawing/2014/main" id="{00000000-0000-0000-0000-000000000019}"/>
               </a:ext>
             </a:extLst>
           </p:cNvPr>
@@ -3094,7 +3094,7 @@
     </p:spTree>
     <p:extLst>
       <p:ext uri="{BB962C8B-B14F-4D97-AF65-F5344CB8AC3E}">
-        <p14:creationId xmlns:p14="http://schemas.microsoft.com/office/powerpoint/2010/main" val="1595836993"/>
+        <p14:creationId xmlns:p14="http://schemas.microsoft.com/office/powerpoint/2010/main" val="20"/>
       </p:ext>
     </p:extLst>
   </p:cSld>
@@ -3125,7 +3125,7 @@
           <p:cNvPr id="5" name="slide-4-title">
             <a:extLst xmlns:a="http://schemas.openxmlformats.org/drawingml/2006/main">
               <a:ext uri="{FF2B5EF4-FFF2-40B4-BE49-F238E27FC236}">
-                <a16:creationId xmlns:a16="http://schemas.microsoft.com/office/drawing/2014/main" id="{4FD1D312-62AD-4D33-A096-366DD70DDE3F}"/>
+                <a16:creationId xmlns:a16="http://schemas.microsoft.com/office/drawing/2014/main" id="{00000000-0000-0000-0000-000000000021}"/>
               </a:ext>
             </a:extLst>
           </p:cNvPr>
@@ -3187,7 +3187,7 @@
           <p:nvPr/>
         </p:nvPicPr>
         <p:blipFill>
-          <a:blip xmlns:r="http://schemas.openxmlformats.org/officeDocument/2006/relationships" xmlns:a="http://schemas.openxmlformats.org/drawingml/2006/main" r:embed="R2ad33671184d4988"/>
+          <a:blip xmlns:r="http://schemas.openxmlformats.org/officeDocument/2006/relationships" xmlns:a="http://schemas.openxmlformats.org/drawingml/2006/main" r:embed="rId2"/>
           <a:stretch xmlns:a="http://schemas.openxmlformats.org/drawingml/2006/main"/>
         </p:blipFill>
         <p:spPr>
@@ -3205,7 +3205,7 @@
           <p:cNvPr id="3" name="optimization-claim">
             <a:extLst xmlns:a="http://schemas.openxmlformats.org/drawingml/2006/main">
               <a:ext uri="{FF2B5EF4-FFF2-40B4-BE49-F238E27FC236}">
-                <a16:creationId xmlns:a16="http://schemas.microsoft.com/office/drawing/2014/main" id="{B43BB884-DEBA-44A2-9871-8714310A2A57}"/>
+                <a16:creationId xmlns:a16="http://schemas.microsoft.com/office/drawing/2014/main" id="{00000000-0000-0000-0000-000000000022}"/>
               </a:ext>
             </a:extLst>
           </p:cNvPr>
@@ -3263,7 +3263,7 @@
           <p:cNvPr id="4" name="optimization-body">
             <a:extLst xmlns:a="http://schemas.openxmlformats.org/drawingml/2006/main">
               <a:ext uri="{FF2B5EF4-FFF2-40B4-BE49-F238E27FC236}">
-                <a16:creationId xmlns:a16="http://schemas.microsoft.com/office/drawing/2014/main" id="{C29BBAA3-559F-4D6F-B304-83613125727D}"/>
+                <a16:creationId xmlns:a16="http://schemas.microsoft.com/office/drawing/2014/main" id="{00000000-0000-0000-0000-000000000023}"/>
               </a:ext>
             </a:extLst>
           </p:cNvPr>
@@ -3347,7 +3347,7 @@
     </p:spTree>
     <p:extLst>
       <p:ext uri="{BB962C8B-B14F-4D97-AF65-F5344CB8AC3E}">
-        <p14:creationId xmlns:p14="http://schemas.microsoft.com/office/powerpoint/2010/main" val="1450763449"/>
+        <p14:creationId xmlns:p14="http://schemas.microsoft.com/office/powerpoint/2010/main" val="24"/>
       </p:ext>
     </p:extLst>
   </p:cSld>
@@ -3378,7 +3378,7 @@
           <p:cNvPr id="5" name="slide-5-title">
             <a:extLst xmlns:a="http://schemas.openxmlformats.org/drawingml/2006/main">
               <a:ext uri="{FF2B5EF4-FFF2-40B4-BE49-F238E27FC236}">
-                <a16:creationId xmlns:a16="http://schemas.microsoft.com/office/drawing/2014/main" id="{2E53F703-C611-4598-ABAB-C9A531827EEC}"/>
+                <a16:creationId xmlns:a16="http://schemas.microsoft.com/office/drawing/2014/main" id="{00000000-0000-0000-0000-000000000025}"/>
               </a:ext>
             </a:extLst>
           </p:cNvPr>
@@ -3440,7 +3440,7 @@
           <p:nvPr/>
         </p:nvPicPr>
         <p:blipFill>
-          <a:blip xmlns:r="http://schemas.openxmlformats.org/officeDocument/2006/relationships" xmlns:a="http://schemas.openxmlformats.org/drawingml/2006/main" r:embed="R62122c299c2f499c"/>
+          <a:blip xmlns:r="http://schemas.openxmlformats.org/officeDocument/2006/relationships" xmlns:a="http://schemas.openxmlformats.org/drawingml/2006/main" r:embed="rId2"/>
           <a:stretch xmlns:a="http://schemas.openxmlformats.org/drawingml/2006/main"/>
         </p:blipFill>
         <p:spPr>
@@ -3458,7 +3458,7 @@
           <p:cNvPr id="3" name="deterministic-claim">
             <a:extLst xmlns:a="http://schemas.openxmlformats.org/drawingml/2006/main">
               <a:ext uri="{FF2B5EF4-FFF2-40B4-BE49-F238E27FC236}">
-                <a16:creationId xmlns:a16="http://schemas.microsoft.com/office/drawing/2014/main" id="{752B321F-A94C-45F7-8C1F-C2CEDCEA3BAC}"/>
+                <a16:creationId xmlns:a16="http://schemas.microsoft.com/office/drawing/2014/main" id="{00000000-0000-0000-0000-000000000026}"/>
               </a:ext>
             </a:extLst>
           </p:cNvPr>
@@ -3516,7 +3516,7 @@
           <p:cNvPr id="4" name="deterministic-body">
             <a:extLst xmlns:a="http://schemas.openxmlformats.org/drawingml/2006/main">
               <a:ext uri="{FF2B5EF4-FFF2-40B4-BE49-F238E27FC236}">
-                <a16:creationId xmlns:a16="http://schemas.microsoft.com/office/drawing/2014/main" id="{EFE1A3C7-0732-4A41-9015-0F1502229B54}"/>
+                <a16:creationId xmlns:a16="http://schemas.microsoft.com/office/drawing/2014/main" id="{00000000-0000-0000-0000-000000000027}"/>
               </a:ext>
             </a:extLst>
           </p:cNvPr>
@@ -3600,7 +3600,7 @@
     </p:spTree>
     <p:extLst>
       <p:ext uri="{BB962C8B-B14F-4D97-AF65-F5344CB8AC3E}">
-        <p14:creationId xmlns:p14="http://schemas.microsoft.com/office/powerpoint/2010/main" val="38188054"/>
+        <p14:creationId xmlns:p14="http://schemas.microsoft.com/office/powerpoint/2010/main" val="28"/>
       </p:ext>
     </p:extLst>
   </p:cSld>
@@ -3631,7 +3631,7 @@
           <p:cNvPr id="5" name="slide-6-title">
             <a:extLst xmlns:a="http://schemas.openxmlformats.org/drawingml/2006/main">
               <a:ext uri="{FF2B5EF4-FFF2-40B4-BE49-F238E27FC236}">
-                <a16:creationId xmlns:a16="http://schemas.microsoft.com/office/drawing/2014/main" id="{FB7FA2DB-77EE-4E2A-8DA7-37EFAC7750F6}"/>
+                <a16:creationId xmlns:a16="http://schemas.microsoft.com/office/drawing/2014/main" id="{00000000-0000-0000-0000-000000000029}"/>
               </a:ext>
             </a:extLst>
           </p:cNvPr>
@@ -3693,7 +3693,7 @@
           <p:nvPr/>
         </p:nvPicPr>
         <p:blipFill>
-          <a:blip xmlns:r="http://schemas.openxmlformats.org/officeDocument/2006/relationships" xmlns:a="http://schemas.openxmlformats.org/drawingml/2006/main" r:embed="R7e1cbd59f5a54b41"/>
+          <a:blip xmlns:r="http://schemas.openxmlformats.org/officeDocument/2006/relationships" xmlns:a="http://schemas.openxmlformats.org/drawingml/2006/main" r:embed="rId2"/>
           <a:stretch xmlns:a="http://schemas.openxmlformats.org/drawingml/2006/main"/>
         </p:blipFill>
         <p:spPr>
@@ -3711,7 +3711,7 @@
           <p:cNvPr id="3" name="stochastic-claim">
             <a:extLst xmlns:a="http://schemas.openxmlformats.org/drawingml/2006/main">
               <a:ext uri="{FF2B5EF4-FFF2-40B4-BE49-F238E27FC236}">
-                <a16:creationId xmlns:a16="http://schemas.microsoft.com/office/drawing/2014/main" id="{F6BA76A3-32EC-46A5-A112-F6A99F36597F}"/>
+                <a16:creationId xmlns:a16="http://schemas.microsoft.com/office/drawing/2014/main" id="{00000000-0000-0000-0000-000000000030}"/>
               </a:ext>
             </a:extLst>
           </p:cNvPr>
@@ -3769,7 +3769,7 @@
           <p:cNvPr id="4" name="stochastic-body">
             <a:extLst xmlns:a="http://schemas.openxmlformats.org/drawingml/2006/main">
               <a:ext uri="{FF2B5EF4-FFF2-40B4-BE49-F238E27FC236}">
-                <a16:creationId xmlns:a16="http://schemas.microsoft.com/office/drawing/2014/main" id="{D7F2EDD9-A44E-4ED3-8C33-282B292E2650}"/>
+                <a16:creationId xmlns:a16="http://schemas.microsoft.com/office/drawing/2014/main" id="{00000000-0000-0000-0000-000000000031}"/>
               </a:ext>
             </a:extLst>
           </p:cNvPr>
@@ -3853,7 +3853,7 @@
     </p:spTree>
     <p:extLst>
       <p:ext uri="{BB962C8B-B14F-4D97-AF65-F5344CB8AC3E}">
-        <p14:creationId xmlns:p14="http://schemas.microsoft.com/office/powerpoint/2010/main" val="1367873802"/>
+        <p14:creationId xmlns:p14="http://schemas.microsoft.com/office/powerpoint/2010/main" val="32"/>
       </p:ext>
     </p:extLst>
   </p:cSld>
@@ -3884,7 +3884,7 @@
           <p:cNvPr id="5" name="slide-7-title">
             <a:extLst xmlns:a="http://schemas.openxmlformats.org/drawingml/2006/main">
               <a:ext uri="{FF2B5EF4-FFF2-40B4-BE49-F238E27FC236}">
-                <a16:creationId xmlns:a16="http://schemas.microsoft.com/office/drawing/2014/main" id="{D63E678F-8E54-49B3-85C8-F15C930A769B}"/>
+                <a16:creationId xmlns:a16="http://schemas.microsoft.com/office/drawing/2014/main" id="{00000000-0000-0000-0000-000000000033}"/>
               </a:ext>
             </a:extLst>
           </p:cNvPr>
@@ -3946,7 +3946,7 @@
           <p:nvPr/>
         </p:nvPicPr>
         <p:blipFill>
-          <a:blip xmlns:r="http://schemas.openxmlformats.org/officeDocument/2006/relationships" xmlns:a="http://schemas.openxmlformats.org/drawingml/2006/main" r:embed="R28826651ec69401d"/>
+          <a:blip xmlns:r="http://schemas.openxmlformats.org/officeDocument/2006/relationships" xmlns:a="http://schemas.openxmlformats.org/drawingml/2006/main" r:embed="rId2"/>
           <a:stretch xmlns:a="http://schemas.openxmlformats.org/drawingml/2006/main"/>
         </p:blipFill>
         <p:spPr>
@@ -3964,7 +3964,7 @@
           <p:cNvPr id="3" name="cartesian-claim">
             <a:extLst xmlns:a="http://schemas.openxmlformats.org/drawingml/2006/main">
               <a:ext uri="{FF2B5EF4-FFF2-40B4-BE49-F238E27FC236}">
-                <a16:creationId xmlns:a16="http://schemas.microsoft.com/office/drawing/2014/main" id="{741683D3-29E5-446C-A2E3-21771BC4DCED}"/>
+                <a16:creationId xmlns:a16="http://schemas.microsoft.com/office/drawing/2014/main" id="{00000000-0000-0000-0000-000000000034}"/>
               </a:ext>
             </a:extLst>
           </p:cNvPr>
@@ -4022,7 +4022,7 @@
           <p:cNvPr id="4" name="cartesian-body">
             <a:extLst xmlns:a="http://schemas.openxmlformats.org/drawingml/2006/main">
               <a:ext uri="{FF2B5EF4-FFF2-40B4-BE49-F238E27FC236}">
-                <a16:creationId xmlns:a16="http://schemas.microsoft.com/office/drawing/2014/main" id="{2A7A8ADF-B25A-4604-8FB0-E3BE4D6C8037}"/>
+                <a16:creationId xmlns:a16="http://schemas.microsoft.com/office/drawing/2014/main" id="{00000000-0000-0000-0000-000000000035}"/>
               </a:ext>
             </a:extLst>
           </p:cNvPr>
@@ -4106,7 +4106,7 @@
     </p:spTree>
     <p:extLst>
       <p:ext uri="{BB962C8B-B14F-4D97-AF65-F5344CB8AC3E}">
-        <p14:creationId xmlns:p14="http://schemas.microsoft.com/office/powerpoint/2010/main" val="231875004"/>
+        <p14:creationId xmlns:p14="http://schemas.microsoft.com/office/powerpoint/2010/main" val="36"/>
       </p:ext>
     </p:extLst>
   </p:cSld>
@@ -4137,7 +4137,7 @@
           <p:cNvPr id="9" name="slide-8-title">
             <a:extLst xmlns:a="http://schemas.openxmlformats.org/drawingml/2006/main">
               <a:ext uri="{FF2B5EF4-FFF2-40B4-BE49-F238E27FC236}">
-                <a16:creationId xmlns:a16="http://schemas.microsoft.com/office/drawing/2014/main" id="{F981B8D5-5B3D-4AF7-A448-3BAF88440CDE}"/>
+                <a16:creationId xmlns:a16="http://schemas.microsoft.com/office/drawing/2014/main" id="{00000000-0000-0000-0000-000000000037}"/>
               </a:ext>
             </a:extLst>
           </p:cNvPr>
@@ -4195,7 +4195,7 @@
           <p:cNvPr id="2" name="cross-validation-metric-1">
             <a:extLst xmlns:a="http://schemas.openxmlformats.org/drawingml/2006/main">
               <a:ext uri="{FF2B5EF4-FFF2-40B4-BE49-F238E27FC236}">
-                <a16:creationId xmlns:a16="http://schemas.microsoft.com/office/drawing/2014/main" id="{B5838379-FA3C-4E0D-AE90-4BA6397EC401}"/>
+                <a16:creationId xmlns:a16="http://schemas.microsoft.com/office/drawing/2014/main" id="{00000000-0000-0000-0000-000000000038}"/>
               </a:ext>
             </a:extLst>
           </p:cNvPr>
@@ -4253,7 +4253,7 @@
           <p:cNvPr id="3" name="cross-validation-metric-label-1">
             <a:extLst xmlns:a="http://schemas.openxmlformats.org/drawingml/2006/main">
               <a:ext uri="{FF2B5EF4-FFF2-40B4-BE49-F238E27FC236}">
-                <a16:creationId xmlns:a16="http://schemas.microsoft.com/office/drawing/2014/main" id="{72C2CC2A-6688-49AB-9372-6BB04412F3AE}"/>
+                <a16:creationId xmlns:a16="http://schemas.microsoft.com/office/drawing/2014/main" id="{00000000-0000-0000-0000-000000000039}"/>
               </a:ext>
             </a:extLst>
           </p:cNvPr>
@@ -4311,7 +4311,7 @@
           <p:cNvPr id="4" name="cross-validation-metric-2">
             <a:extLst xmlns:a="http://schemas.openxmlformats.org/drawingml/2006/main">
               <a:ext uri="{FF2B5EF4-FFF2-40B4-BE49-F238E27FC236}">
-                <a16:creationId xmlns:a16="http://schemas.microsoft.com/office/drawing/2014/main" id="{FDF8650E-1001-4E62-8485-A0758F5B6D38}"/>
+                <a16:creationId xmlns:a16="http://schemas.microsoft.com/office/drawing/2014/main" id="{00000000-0000-0000-0000-000000000040}"/>
               </a:ext>
             </a:extLst>
           </p:cNvPr>
@@ -4369,7 +4369,7 @@
           <p:cNvPr id="5" name="cross-validation-metric-label-2">
             <a:extLst xmlns:a="http://schemas.openxmlformats.org/drawingml/2006/main">
               <a:ext uri="{FF2B5EF4-FFF2-40B4-BE49-F238E27FC236}">
-                <a16:creationId xmlns:a16="http://schemas.microsoft.com/office/drawing/2014/main" id="{E50402F1-A1C3-47D7-9004-71E6DC721B72}"/>
+                <a16:creationId xmlns:a16="http://schemas.microsoft.com/office/drawing/2014/main" id="{00000000-0000-0000-0000-000000000041}"/>
               </a:ext>
             </a:extLst>
           </p:cNvPr>
@@ -4427,7 +4427,7 @@
           <p:cNvPr id="6" name="cross-validation-metric-3">
             <a:extLst xmlns:a="http://schemas.openxmlformats.org/drawingml/2006/main">
               <a:ext uri="{FF2B5EF4-FFF2-40B4-BE49-F238E27FC236}">
-                <a16:creationId xmlns:a16="http://schemas.microsoft.com/office/drawing/2014/main" id="{2D59E4E3-EA8E-43DC-B3B6-9D5F20EBA687}"/>
+                <a16:creationId xmlns:a16="http://schemas.microsoft.com/office/drawing/2014/main" id="{00000000-0000-0000-0000-000000000042}"/>
               </a:ext>
             </a:extLst>
           </p:cNvPr>
@@ -4485,7 +4485,7 @@
           <p:cNvPr id="7" name="cross-validation-metric-label-3">
             <a:extLst xmlns:a="http://schemas.openxmlformats.org/drawingml/2006/main">
               <a:ext uri="{FF2B5EF4-FFF2-40B4-BE49-F238E27FC236}">
-                <a16:creationId xmlns:a16="http://schemas.microsoft.com/office/drawing/2014/main" id="{F07DDE4E-74D1-4D0E-B69F-1EBFA19F9118}"/>
+                <a16:creationId xmlns:a16="http://schemas.microsoft.com/office/drawing/2014/main" id="{00000000-0000-0000-0000-000000000043}"/>
               </a:ext>
             </a:extLst>
           </p:cNvPr>
@@ -4543,7 +4543,7 @@
           <p:cNvPr id="8" name="cross-validation-interpretation">
             <a:extLst xmlns:a="http://schemas.openxmlformats.org/drawingml/2006/main">
               <a:ext uri="{FF2B5EF4-FFF2-40B4-BE49-F238E27FC236}">
-                <a16:creationId xmlns:a16="http://schemas.microsoft.com/office/drawing/2014/main" id="{A222B6D0-C44C-40F6-8505-8F6143CA606F}"/>
+                <a16:creationId xmlns:a16="http://schemas.microsoft.com/office/drawing/2014/main" id="{00000000-0000-0000-0000-000000000044}"/>
               </a:ext>
             </a:extLst>
           </p:cNvPr>
@@ -4599,7 +4599,7 @@
     </p:spTree>
     <p:extLst>
       <p:ext uri="{BB962C8B-B14F-4D97-AF65-F5344CB8AC3E}">
-        <p14:creationId xmlns:p14="http://schemas.microsoft.com/office/powerpoint/2010/main" val="1527312909"/>
+        <p14:creationId xmlns:p14="http://schemas.microsoft.com/office/powerpoint/2010/main" val="45"/>
       </p:ext>
     </p:extLst>
   </p:cSld>
@@ -4630,7 +4630,7 @@
           <p:cNvPr id="9" name="slide-9-title">
             <a:extLst xmlns:a="http://schemas.openxmlformats.org/drawingml/2006/main">
               <a:ext uri="{FF2B5EF4-FFF2-40B4-BE49-F238E27FC236}">
-                <a16:creationId xmlns:a16="http://schemas.microsoft.com/office/drawing/2014/main" id="{C1F1E7D4-6D24-4B1F-969A-C0E2E3D744B0}"/>
+                <a16:creationId xmlns:a16="http://schemas.microsoft.com/office/drawing/2014/main" id="{00000000-0000-0000-0000-000000000046}"/>
               </a:ext>
             </a:extLst>
           </p:cNvPr>
@@ -4711,7 +4711,7 @@
           <p:cNvPr id="2" name="conclusion-metric-1">
             <a:extLst xmlns:a="http://schemas.openxmlformats.org/drawingml/2006/main">
               <a:ext uri="{FF2B5EF4-FFF2-40B4-BE49-F238E27FC236}">
-                <a16:creationId xmlns:a16="http://schemas.microsoft.com/office/drawing/2014/main" id="{6CEEAD44-64E3-4FF8-A400-3DDC82411AE6}"/>
+                <a16:creationId xmlns:a16="http://schemas.microsoft.com/office/drawing/2014/main" id="{00000000-0000-0000-0000-000000000047}"/>
               </a:ext>
             </a:extLst>
           </p:cNvPr>
@@ -4769,7 +4769,7 @@
           <p:cNvPr id="3" name="conclusion-metric-label-1">
             <a:extLst xmlns:a="http://schemas.openxmlformats.org/drawingml/2006/main">
               <a:ext uri="{FF2B5EF4-FFF2-40B4-BE49-F238E27FC236}">
-                <a16:creationId xmlns:a16="http://schemas.microsoft.com/office/drawing/2014/main" id="{8D5FD1E3-101D-4B8D-BEE8-9F9EEE65BB57}"/>
+                <a16:creationId xmlns:a16="http://schemas.microsoft.com/office/drawing/2014/main" id="{00000000-0000-0000-0000-000000000048}"/>
               </a:ext>
             </a:extLst>
           </p:cNvPr>
@@ -4827,7 +4827,7 @@
           <p:cNvPr id="4" name="conclusion-metric-2">
             <a:extLst xmlns:a="http://schemas.openxmlformats.org/drawingml/2006/main">
               <a:ext uri="{FF2B5EF4-FFF2-40B4-BE49-F238E27FC236}">
-                <a16:creationId xmlns:a16="http://schemas.microsoft.com/office/drawing/2014/main" id="{E02E124D-AFCD-441A-A6CE-AC214A2B7764}"/>
+                <a16:creationId xmlns:a16="http://schemas.microsoft.com/office/drawing/2014/main" id="{00000000-0000-0000-0000-000000000049}"/>
               </a:ext>
             </a:extLst>
           </p:cNvPr>
@@ -4885,7 +4885,7 @@
           <p:cNvPr id="5" name="conclusion-metric-label-2">
             <a:extLst xmlns:a="http://schemas.openxmlformats.org/drawingml/2006/main">
               <a:ext uri="{FF2B5EF4-FFF2-40B4-BE49-F238E27FC236}">
-                <a16:creationId xmlns:a16="http://schemas.microsoft.com/office/drawing/2014/main" id="{DC90107B-E9B7-4B57-90F4-02A960D250FD}"/>
+                <a16:creationId xmlns:a16="http://schemas.microsoft.com/office/drawing/2014/main" id="{00000000-0000-0000-0000-000000000050}"/>
               </a:ext>
             </a:extLst>
           </p:cNvPr>
@@ -4943,7 +4943,7 @@
           <p:cNvPr id="6" name="conclusion-metric-3">
             <a:extLst xmlns:a="http://schemas.openxmlformats.org/drawingml/2006/main">
               <a:ext uri="{FF2B5EF4-FFF2-40B4-BE49-F238E27FC236}">
-                <a16:creationId xmlns:a16="http://schemas.microsoft.com/office/drawing/2014/main" id="{D46B9DDA-26CE-40F1-AFBD-71139B8E6E8E}"/>
+                <a16:creationId xmlns:a16="http://schemas.microsoft.com/office/drawing/2014/main" id="{00000000-0000-0000-0000-000000000051}"/>
               </a:ext>
             </a:extLst>
           </p:cNvPr>
@@ -5001,7 +5001,7 @@
           <p:cNvPr id="7" name="conclusion-metric-label-3">
             <a:extLst xmlns:a="http://schemas.openxmlformats.org/drawingml/2006/main">
               <a:ext uri="{FF2B5EF4-FFF2-40B4-BE49-F238E27FC236}">
-                <a16:creationId xmlns:a16="http://schemas.microsoft.com/office/drawing/2014/main" id="{56612BB8-C529-4DF6-BB94-F2C209C48995}"/>
+                <a16:creationId xmlns:a16="http://schemas.microsoft.com/office/drawing/2014/main" id="{00000000-0000-0000-0000-000000000052}"/>
               </a:ext>
             </a:extLst>
           </p:cNvPr>
@@ -5059,7 +5059,7 @@
           <p:cNvPr id="8" name="conclusion-interpretation">
             <a:extLst xmlns:a="http://schemas.openxmlformats.org/drawingml/2006/main">
               <a:ext uri="{FF2B5EF4-FFF2-40B4-BE49-F238E27FC236}">
-                <a16:creationId xmlns:a16="http://schemas.microsoft.com/office/drawing/2014/main" id="{A9F21930-B7D2-4100-B64F-30D2DF21E9DC}"/>
+                <a16:creationId xmlns:a16="http://schemas.microsoft.com/office/drawing/2014/main" id="{00000000-0000-0000-0000-000000000053}"/>
               </a:ext>
             </a:extLst>
           </p:cNvPr>
@@ -5115,7 +5115,7 @@
     </p:spTree>
     <p:extLst>
       <p:ext uri="{BB962C8B-B14F-4D97-AF65-F5344CB8AC3E}">
-        <p14:creationId xmlns:p14="http://schemas.microsoft.com/office/powerpoint/2010/main" val="1411863813"/>
+        <p14:creationId xmlns:p14="http://schemas.microsoft.com/office/powerpoint/2010/main" val="54"/>
       </p:ext>
     </p:extLst>
   </p:cSld>

</xml_diff>

<commit_message>
fix: close Phase 7B audit warnings
</commit_message>
<xml_diff>
--- a/presentation/final_presentation.pptx
+++ b/presentation/final_presentation.pptx
@@ -934,6 +934,11 @@
               <a:t>- results/data/deterministic_robustness_summary.csv</a:t>
             </a:r>
           </a:p>
+          <a:p xmlns:a="http://schemas.openxmlformats.org/drawingml/2006/main">
+            <a:r>
+              <a:t>- results/data/deterministic_robustness_runs.csv</a:t>
+            </a:r>
+          </a:p>
         </p:txBody>
       </p:sp>
       <p:sp>
@@ -1027,6 +1032,11 @@
           <a:p xmlns:a="http://schemas.openxmlformats.org/drawingml/2006/main">
             <a:r>
               <a:t>- results/data/stochastic_robustness_summary.csv</a:t>
+            </a:r>
+          </a:p>
+          <a:p xmlns:a="http://schemas.openxmlformats.org/drawingml/2006/main">
+            <a:r>
+              <a:t>- results/data/stochastic_robustness_trials.csv</a:t>
             </a:r>
           </a:p>
         </p:txBody>
@@ -5107,7 +5117,7 @@
                 <a:ea typeface="Arial"/>
                 <a:cs typeface="Arial"/>
               </a:rPr>
-              <a:t>Fuzzy adaptation gives a small nominal joint-2 benefit; optimized PID provides the best aggregate deterministic and Cartesian reliability, with a torque-slew trade-off under noise.</a:t>
+              <a:t>Fuzzy-PID's nominal advantage is limited to joint-2 steady-state RMS; optimized PID provides the best aggregate deterministic and Cartesian reliability, with a torque-slew trade-off under noise.</a:t>
             </a:r>
           </a:p>
         </p:txBody>

</xml_diff>

<commit_message>
fix: close Phase 7B final review gaps
</commit_message>
<xml_diff>
--- a/presentation/final_presentation.pptx
+++ b/presentation/final_presentation.pptx
@@ -2079,262 +2079,262 @@
 </file>
 
 <file path=ppt/slides/slide10.xml><?xml version="1.0" encoding="utf-8"?>
-<p:sld xmlns:p="http://schemas.openxmlformats.org/presentationml/2006/main">
-  <p:cSld>
-    <p:bg>
-      <p:bgPr>
-        <a:solidFill xmlns:a="http://schemas.openxmlformats.org/drawingml/2006/main">
-          <a:srgbClr val="FFFFFF"/>
-        </a:solidFill>
-      </p:bgPr>
-    </p:bg>
-    <p:spTree>
-      <p:nvGrpSpPr>
-        <p:cNvPr id="1" name=""/>
-        <p:cNvGrpSpPr/>
-        <p:nvPr/>
-      </p:nvGrpSpPr>
-      <p:grpSpPr>
-        <a:xfrm xmlns:a="http://schemas.openxmlformats.org/drawingml/2006/main"/>
-      </p:grpSpPr>
-      <p:sp>
-        <p:nvSpPr>
-          <p:cNvPr id="4" name="slide-10-title">
-            <a:extLst xmlns:a="http://schemas.openxmlformats.org/drawingml/2006/main">
-              <a:ext uri="{FF2B5EF4-FFF2-40B4-BE49-F238E27FC236}">
-                <a16:creationId xmlns:a16="http://schemas.microsoft.com/office/drawing/2014/main" id="{00000000-0000-0000-0000-000000000004}"/>
-              </a:ext>
-            </a:extLst>
-          </p:cNvPr>
-          <p:cNvSpPr>
-            <a:spLocks xmlns:a="http://schemas.openxmlformats.org/drawingml/2006/main" noGrp="1"/>
-          </p:cNvSpPr>
-          <p:nvPr/>
-        </p:nvSpPr>
-        <p:spPr>
-          <a:xfrm xmlns:a="http://schemas.openxmlformats.org/drawingml/2006/main">
-            <a:off x="495300" y="323850"/>
-            <a:ext cx="11125200" cy="685800"/>
-          </a:xfrm>
-          <a:prstGeom xmlns:a="http://schemas.openxmlformats.org/drawingml/2006/main" prst="rect">
-            <a:avLst/>
-          </a:prstGeom>
-          <a:noFill xmlns:a="http://schemas.openxmlformats.org/drawingml/2006/main"/>
-          <a:ln xmlns:a="http://schemas.openxmlformats.org/drawingml/2006/main" w="0">
-            <a:noFill/>
-            <a:prstDash val="solid"/>
-          </a:ln>
-        </p:spPr>
-        <p:txBody>
-          <a:bodyPr xmlns:a="http://schemas.openxmlformats.org/drawingml/2006/main">
-            <a:normAutofit fontScale="82082"/>
-          </a:bodyPr>
-          <a:lstStyle xmlns:a="http://schemas.openxmlformats.org/drawingml/2006/main"/>
-          <a:p xmlns:a="http://schemas.openxmlformats.org/drawingml/2006/main">
-            <a:pPr>
-              <a:defRPr sz="3600" b="1">
-                <a:solidFill>
-                  <a:srgbClr val="000000"/>
-                </a:solidFill>
-                <a:latin typeface="Arial"/>
-                <a:ea typeface="Arial"/>
-                <a:cs typeface="Arial"/>
-              </a:defRPr>
-            </a:pPr>
-            <a:r>
-              <a:rPr sz="3600" b="1">
-                <a:solidFill>
-                  <a:srgbClr val="000000"/>
-                </a:solidFill>
-                <a:latin typeface="Arial"/>
-                <a:ea typeface="Arial"/>
-                <a:cs typeface="Arial"/>
-              </a:rPr>
-              <a:t>The validated layer is ready to support the next research step</a:t>
-            </a:r>
-          </a:p>
-        </p:txBody>
-      </p:sp>
-      <p:sp>
-        <p:nvSpPr>
-          <p:cNvPr id="2" name="next-steps-lead">
-            <a:extLst xmlns:a="http://schemas.openxmlformats.org/drawingml/2006/main">
-              <a:ext uri="{FF2B5EF4-FFF2-40B4-BE49-F238E27FC236}">
-                <a16:creationId xmlns:a16="http://schemas.microsoft.com/office/drawing/2014/main" id="{00000000-0000-0000-0000-000000000005}"/>
-              </a:ext>
-            </a:extLst>
-          </p:cNvPr>
-          <p:cNvSpPr>
-            <a:spLocks xmlns:a="http://schemas.openxmlformats.org/drawingml/2006/main" noGrp="1"/>
-          </p:cNvSpPr>
-          <p:nvPr/>
-        </p:nvSpPr>
-        <p:spPr>
-          <a:xfrm xmlns:a="http://schemas.openxmlformats.org/drawingml/2006/main">
-            <a:off x="495300" y="1524000"/>
-            <a:ext cx="10668000" cy="1333500"/>
-          </a:xfrm>
-          <a:prstGeom xmlns:a="http://schemas.openxmlformats.org/drawingml/2006/main" prst="rect">
-            <a:avLst/>
-          </a:prstGeom>
-          <a:noFill xmlns:a="http://schemas.openxmlformats.org/drawingml/2006/main"/>
-          <a:ln xmlns:a="http://schemas.openxmlformats.org/drawingml/2006/main" w="0">
-            <a:noFill/>
-            <a:prstDash val="solid"/>
-          </a:ln>
-        </p:spPr>
-        <p:txBody>
-          <a:bodyPr xmlns:a="http://schemas.openxmlformats.org/drawingml/2006/main" anchor="t">
-            <a:normAutofit fontScale="86243"/>
-          </a:bodyPr>
-          <a:lstStyle xmlns:a="http://schemas.openxmlformats.org/drawingml/2006/main"/>
-          <a:p xmlns:a="http://schemas.openxmlformats.org/drawingml/2006/main">
-            <a:pPr algn="l">
-              <a:defRPr sz="3150" b="1">
-                <a:solidFill>
-                  <a:srgbClr val="000000"/>
-                </a:solidFill>
-                <a:latin typeface="Arial"/>
-                <a:ea typeface="Arial"/>
-                <a:cs typeface="Arial"/>
-              </a:defRPr>
-            </a:pPr>
-            <a:r>
-              <a:rPr sz="3150" b="1">
-                <a:solidFill>
-                  <a:srgbClr val="000000"/>
-                </a:solidFill>
-                <a:latin typeface="Arial"/>
-                <a:ea typeface="Arial"/>
-                <a:cs typeface="Arial"/>
-              </a:rPr>
-              <a:t>The next milestone is to test whether the same evidence discipline survives contact with sensing, hardware uncertainty, and online safety constraints.</a:t>
-            </a:r>
-          </a:p>
-        </p:txBody>
-      </p:sp>
-      <p:sp>
-        <p:nvSpPr>
-          <p:cNvPr id="3" name="next-steps-steps">
-            <a:extLst xmlns:a="http://schemas.openxmlformats.org/drawingml/2006/main">
-              <a:ext uri="{FF2B5EF4-FFF2-40B4-BE49-F238E27FC236}">
-                <a16:creationId xmlns:a16="http://schemas.microsoft.com/office/drawing/2014/main" id="{00000000-0000-0000-0000-000000000006}"/>
-              </a:ext>
-            </a:extLst>
-          </p:cNvPr>
-          <p:cNvSpPr>
-            <a:spLocks xmlns:a="http://schemas.openxmlformats.org/drawingml/2006/main" noGrp="1"/>
-          </p:cNvSpPr>
-          <p:nvPr/>
-        </p:nvSpPr>
-        <p:spPr>
-          <a:xfrm xmlns:a="http://schemas.openxmlformats.org/drawingml/2006/main">
-            <a:off x="495300" y="3238500"/>
-            <a:ext cx="10668000" cy="2571750"/>
-          </a:xfrm>
-          <a:prstGeom xmlns:a="http://schemas.openxmlformats.org/drawingml/2006/main" prst="rect">
-            <a:avLst/>
-          </a:prstGeom>
-          <a:noFill xmlns:a="http://schemas.openxmlformats.org/drawingml/2006/main"/>
-          <a:ln xmlns:a="http://schemas.openxmlformats.org/drawingml/2006/main" w="0">
-            <a:noFill/>
-            <a:prstDash val="solid"/>
-          </a:ln>
-        </p:spPr>
-        <p:txBody>
-          <a:bodyPr xmlns:a="http://schemas.openxmlformats.org/drawingml/2006/main" anchor="t">
-            <a:normAutofit fontScale="100000"/>
-          </a:bodyPr>
-          <a:lstStyle xmlns:a="http://schemas.openxmlformats.org/drawingml/2006/main"/>
-          <a:p xmlns:a="http://schemas.openxmlformats.org/drawingml/2006/main">
-            <a:pPr algn="l">
-              <a:defRPr sz="2100" b="0">
-                <a:solidFill>
-                  <a:srgbClr val="000000"/>
-                </a:solidFill>
-                <a:latin typeface="Arial"/>
-                <a:ea typeface="Arial"/>
-                <a:cs typeface="Arial"/>
-              </a:defRPr>
-            </a:pPr>
-            <a:r>
-              <a:rPr sz="2100" b="0">
-                <a:solidFill>
-                  <a:srgbClr val="000000"/>
-                </a:solidFill>
-                <a:latin typeface="Arial"/>
-                <a:ea typeface="Arial"/>
-                <a:cs typeface="Arial"/>
-              </a:rPr>
-              <a:t>1. Hardware-in-the-loop and physical-arm validation with calibrated uncertainty.</a:t>
-            </a:r>
-          </a:p>
-          <a:p xmlns:a="http://schemas.openxmlformats.org/drawingml/2006/main">
-            <a:r>
-              <a:t/>
-            </a:r>
-          </a:p>
-          <a:p xmlns:a="http://schemas.openxmlformats.org/drawingml/2006/main">
-            <a:pPr algn="l">
-              <a:defRPr sz="2100" b="0">
-                <a:solidFill>
-                  <a:srgbClr val="000000"/>
-                </a:solidFill>
-                <a:latin typeface="Arial"/>
-                <a:ea typeface="Arial"/>
-                <a:cs typeface="Arial"/>
-              </a:defRPr>
-            </a:pPr>
-            <a:r>
-              <a:rPr sz="2100" b="0">
-                <a:solidFill>
-                  <a:srgbClr val="000000"/>
-                </a:solidFill>
-                <a:latin typeface="Arial"/>
-                <a:ea typeface="Arial"/>
-                <a:cs typeface="Arial"/>
-              </a:rPr>
-              <a:t>2. Perception and task-planning integration above the existing inner-loop controller layer.</a:t>
-            </a:r>
-          </a:p>
-          <a:p xmlns:a="http://schemas.openxmlformats.org/drawingml/2006/main">
-            <a:r>
-              <a:t/>
-            </a:r>
-          </a:p>
-          <a:p xmlns:a="http://schemas.openxmlformats.org/drawingml/2006/main">
-            <a:pPr algn="l">
-              <a:defRPr sz="2100" b="0">
-                <a:solidFill>
-                  <a:srgbClr val="000000"/>
-                </a:solidFill>
-                <a:latin typeface="Arial"/>
-                <a:ea typeface="Arial"/>
-                <a:cs typeface="Arial"/>
-              </a:defRPr>
-            </a:pPr>
-            <a:r>
-              <a:rPr sz="2100" b="0">
-                <a:solidFill>
-                  <a:srgbClr val="000000"/>
-                </a:solidFill>
-                <a:latin typeface="Arial"/>
-                <a:ea typeface="Arial"/>
-                <a:cs typeface="Arial"/>
-              </a:rPr>
-              <a:t>3. Online monitoring, collision avoidance, and explicit safety supervision before deployment.</a:t>
-            </a:r>
-          </a:p>
-        </p:txBody>
-      </p:sp>
-    </p:spTree>
-    <p:extLst>
-      <p:ext uri="{BB962C8B-B14F-4D97-AF65-F5344CB8AC3E}">
-        <p14:creationId xmlns:p14="http://schemas.microsoft.com/office/powerpoint/2010/main" val="7"/>
-      </p:ext>
-    </p:extLst>
-  </p:cSld>
-</p:sld>
+<ns0:sld xmlns:ns0="http://schemas.openxmlformats.org/presentationml/2006/main" xmlns:ns1="http://schemas.openxmlformats.org/drawingml/2006/main" xmlns:ns2="http://schemas.microsoft.com/office/drawing/2014/main" xmlns:ns3="http://schemas.microsoft.com/office/powerpoint/2010/main">
+  <ns0:cSld>
+    <ns0:bg>
+      <ns0:bgPr>
+        <ns1:solidFill>
+          <ns1:srgbClr val="FFFFFF"/>
+        </ns1:solidFill>
+      </ns0:bgPr>
+    </ns0:bg>
+    <ns0:spTree>
+      <ns0:nvGrpSpPr>
+        <ns0:cNvPr id="1" name=""/>
+        <ns0:cNvGrpSpPr/>
+        <ns0:nvPr/>
+      </ns0:nvGrpSpPr>
+      <ns0:grpSpPr>
+        <ns1:xfrm/>
+      </ns0:grpSpPr>
+      <ns0:sp>
+        <ns0:nvSpPr>
+          <ns0:cNvPr id="4" name="slide-10-title">
+            <ns1:extLst>
+              <ns1:ext uri="{FF2B5EF4-FFF2-40B4-BE49-F238E27FC236}">
+                <ns2:creationId id="{00000000-0000-0000-0000-000000000004}"/>
+              </ns1:ext>
+            </ns1:extLst>
+          </ns0:cNvPr>
+          <ns0:cNvSpPr>
+            <ns1:spLocks noGrp="1"/>
+          </ns0:cNvSpPr>
+          <ns0:nvPr/>
+        </ns0:nvSpPr>
+        <ns0:spPr>
+          <ns1:xfrm>
+            <ns1:off x="495300" y="323850"/>
+            <ns1:ext cx="11125200" cy="685800"/>
+          </ns1:xfrm>
+          <ns1:prstGeom prst="rect">
+            <ns1:avLst/>
+          </ns1:prstGeom>
+          <ns1:noFill/>
+          <ns1:ln w="0">
+            <ns1:noFill/>
+            <ns1:prstDash val="solid"/>
+          </ns1:ln>
+        </ns0:spPr>
+        <ns0:txBody>
+          <ns1:bodyPr>
+            <ns1:normAutofit fontScale="100000"/>
+          </ns1:bodyPr>
+          <ns1:lstStyle/>
+          <ns1:p>
+            <ns1:pPr>
+              <ns1:defRPr sz="3600" b="1">
+                <ns1:solidFill>
+                  <ns1:srgbClr val="000000"/>
+                </ns1:solidFill>
+                <ns1:latin typeface="Arial"/>
+                <ns1:ea typeface="Arial"/>
+                <ns1:cs typeface="Arial"/>
+              </ns1:defRPr>
+            </ns1:pPr>
+            <ns1:r>
+              <ns1:rPr sz="3600" b="1">
+                <ns1:solidFill>
+                  <ns1:srgbClr val="000000"/>
+                </ns1:solidFill>
+                <ns1:latin typeface="Arial"/>
+                <ns1:ea typeface="Arial"/>
+                <ns1:cs typeface="Arial"/>
+              </ns1:rPr>
+              <ns1:t>Validated layer supports the next research step</ns1:t>
+            </ns1:r>
+          </ns1:p>
+        </ns0:txBody>
+      </ns0:sp>
+      <ns0:sp>
+        <ns0:nvSpPr>
+          <ns0:cNvPr id="2" name="next-steps-lead">
+            <ns1:extLst>
+              <ns1:ext uri="{FF2B5EF4-FFF2-40B4-BE49-F238E27FC236}">
+                <ns2:creationId id="{00000000-0000-0000-0000-000000000005}"/>
+              </ns1:ext>
+            </ns1:extLst>
+          </ns0:cNvPr>
+          <ns0:cNvSpPr>
+            <ns1:spLocks noGrp="1"/>
+          </ns0:cNvSpPr>
+          <ns0:nvPr/>
+        </ns0:nvSpPr>
+        <ns0:spPr>
+          <ns1:xfrm>
+            <ns1:off x="495300" y="1524000"/>
+            <ns1:ext cx="10668000" cy="1333500"/>
+          </ns1:xfrm>
+          <ns1:prstGeom prst="rect">
+            <ns1:avLst/>
+          </ns1:prstGeom>
+          <ns1:noFill/>
+          <ns1:ln w="0">
+            <ns1:noFill/>
+            <ns1:prstDash val="solid"/>
+          </ns1:ln>
+        </ns0:spPr>
+        <ns0:txBody>
+          <ns1:bodyPr anchor="t">
+            <ns1:normAutofit fontScale="86243"/>
+          </ns1:bodyPr>
+          <ns1:lstStyle/>
+          <ns1:p>
+            <ns1:pPr algn="l">
+              <ns1:defRPr sz="3150" b="1">
+                <ns1:solidFill>
+                  <ns1:srgbClr val="000000"/>
+                </ns1:solidFill>
+                <ns1:latin typeface="Arial"/>
+                <ns1:ea typeface="Arial"/>
+                <ns1:cs typeface="Arial"/>
+              </ns1:defRPr>
+            </ns1:pPr>
+            <ns1:r>
+              <ns1:rPr sz="3150" b="1">
+                <ns1:solidFill>
+                  <ns1:srgbClr val="000000"/>
+                </ns1:solidFill>
+                <ns1:latin typeface="Arial"/>
+                <ns1:ea typeface="Arial"/>
+                <ns1:cs typeface="Arial"/>
+              </ns1:rPr>
+              <ns1:t>The next milestone is to test whether the same evidence discipline survives contact with sensing, hardware uncertainty, and online safety constraints.</ns1:t>
+            </ns1:r>
+          </ns1:p>
+        </ns0:txBody>
+      </ns0:sp>
+      <ns0:sp>
+        <ns0:nvSpPr>
+          <ns0:cNvPr id="3" name="next-steps-steps">
+            <ns1:extLst>
+              <ns1:ext uri="{FF2B5EF4-FFF2-40B4-BE49-F238E27FC236}">
+                <ns2:creationId id="{00000000-0000-0000-0000-000000000006}"/>
+              </ns1:ext>
+            </ns1:extLst>
+          </ns0:cNvPr>
+          <ns0:cNvSpPr>
+            <ns1:spLocks noGrp="1"/>
+          </ns0:cNvSpPr>
+          <ns0:nvPr/>
+        </ns0:nvSpPr>
+        <ns0:spPr>
+          <ns1:xfrm>
+            <ns1:off x="495300" y="3238500"/>
+            <ns1:ext cx="10668000" cy="2571750"/>
+          </ns1:xfrm>
+          <ns1:prstGeom prst="rect">
+            <ns1:avLst/>
+          </ns1:prstGeom>
+          <ns1:noFill/>
+          <ns1:ln w="0">
+            <ns1:noFill/>
+            <ns1:prstDash val="solid"/>
+          </ns1:ln>
+        </ns0:spPr>
+        <ns0:txBody>
+          <ns1:bodyPr anchor="t">
+            <ns1:normAutofit fontScale="100000"/>
+          </ns1:bodyPr>
+          <ns1:lstStyle/>
+          <ns1:p>
+            <ns1:pPr algn="l">
+              <ns1:defRPr sz="2100" b="0">
+                <ns1:solidFill>
+                  <ns1:srgbClr val="000000"/>
+                </ns1:solidFill>
+                <ns1:latin typeface="Arial"/>
+                <ns1:ea typeface="Arial"/>
+                <ns1:cs typeface="Arial"/>
+              </ns1:defRPr>
+            </ns1:pPr>
+            <ns1:r>
+              <ns1:rPr sz="2100" b="0">
+                <ns1:solidFill>
+                  <ns1:srgbClr val="000000"/>
+                </ns1:solidFill>
+                <ns1:latin typeface="Arial"/>
+                <ns1:ea typeface="Arial"/>
+                <ns1:cs typeface="Arial"/>
+              </ns1:rPr>
+              <ns1:t>1. Hardware-in-the-loop and physical-arm validation with calibrated uncertainty.</ns1:t>
+            </ns1:r>
+          </ns1:p>
+          <ns1:p>
+            <ns1:r>
+              <ns1:t/>
+            </ns1:r>
+          </ns1:p>
+          <ns1:p>
+            <ns1:pPr algn="l">
+              <ns1:defRPr sz="2100" b="0">
+                <ns1:solidFill>
+                  <ns1:srgbClr val="000000"/>
+                </ns1:solidFill>
+                <ns1:latin typeface="Arial"/>
+                <ns1:ea typeface="Arial"/>
+                <ns1:cs typeface="Arial"/>
+              </ns1:defRPr>
+            </ns1:pPr>
+            <ns1:r>
+              <ns1:rPr sz="2100" b="0">
+                <ns1:solidFill>
+                  <ns1:srgbClr val="000000"/>
+                </ns1:solidFill>
+                <ns1:latin typeface="Arial"/>
+                <ns1:ea typeface="Arial"/>
+                <ns1:cs typeface="Arial"/>
+              </ns1:rPr>
+              <ns1:t>2. Perception and task-planning integration above the existing inner-loop controller layer.</ns1:t>
+            </ns1:r>
+          </ns1:p>
+          <ns1:p>
+            <ns1:r>
+              <ns1:t/>
+            </ns1:r>
+          </ns1:p>
+          <ns1:p>
+            <ns1:pPr algn="l">
+              <ns1:defRPr sz="2100" b="0">
+                <ns1:solidFill>
+                  <ns1:srgbClr val="000000"/>
+                </ns1:solidFill>
+                <ns1:latin typeface="Arial"/>
+                <ns1:ea typeface="Arial"/>
+                <ns1:cs typeface="Arial"/>
+              </ns1:defRPr>
+            </ns1:pPr>
+            <ns1:r>
+              <ns1:rPr sz="2100" b="0">
+                <ns1:solidFill>
+                  <ns1:srgbClr val="000000"/>
+                </ns1:solidFill>
+                <ns1:latin typeface="Arial"/>
+                <ns1:ea typeface="Arial"/>
+                <ns1:cs typeface="Arial"/>
+              </ns1:rPr>
+              <ns1:t>3. Online monitoring, collision avoidance, and explicit safety supervision before deployment.</ns1:t>
+            </ns1:r>
+          </ns1:p>
+        </ns0:txBody>
+      </ns0:sp>
+    </ns0:spTree>
+    <ns0:extLst>
+      <ns0:ext uri="{BB962C8B-B14F-4D97-AF65-F5344CB8AC3E}">
+        <ns3:creationId val="7"/>
+      </ns0:ext>
+    </ns0:extLst>
+  </ns0:cSld>
+</ns0:sld>
 </file>
 
 <file path=ppt/slides/slide2.xml><?xml version="1.0" encoding="utf-8"?>
@@ -3618,256 +3618,256 @@
 </file>
 
 <file path=ppt/slides/slide6.xml><?xml version="1.0" encoding="utf-8"?>
-<p:sld xmlns:p="http://schemas.openxmlformats.org/presentationml/2006/main">
-  <p:cSld>
-    <p:bg>
-      <p:bgPr>
-        <a:solidFill xmlns:a="http://schemas.openxmlformats.org/drawingml/2006/main">
-          <a:srgbClr val="FFFFFF"/>
-        </a:solidFill>
-      </p:bgPr>
-    </p:bg>
-    <p:spTree>
-      <p:nvGrpSpPr>
-        <p:cNvPr id="1" name=""/>
-        <p:cNvGrpSpPr/>
-        <p:nvPr/>
-      </p:nvGrpSpPr>
-      <p:grpSpPr>
-        <a:xfrm xmlns:a="http://schemas.openxmlformats.org/drawingml/2006/main"/>
-      </p:grpSpPr>
-      <p:sp>
-        <p:nvSpPr>
-          <p:cNvPr id="5" name="slide-6-title">
-            <a:extLst xmlns:a="http://schemas.openxmlformats.org/drawingml/2006/main">
-              <a:ext uri="{FF2B5EF4-FFF2-40B4-BE49-F238E27FC236}">
-                <a16:creationId xmlns:a16="http://schemas.microsoft.com/office/drawing/2014/main" id="{00000000-0000-0000-0000-000000000029}"/>
-              </a:ext>
-            </a:extLst>
-          </p:cNvPr>
-          <p:cNvSpPr>
-            <a:spLocks xmlns:a="http://schemas.openxmlformats.org/drawingml/2006/main" noGrp="1"/>
-          </p:cNvSpPr>
-          <p:nvPr/>
-        </p:nvSpPr>
-        <p:spPr>
-          <a:xfrm xmlns:a="http://schemas.openxmlformats.org/drawingml/2006/main">
-            <a:off x="495300" y="323850"/>
-            <a:ext cx="11125200" cy="685800"/>
-          </a:xfrm>
-          <a:prstGeom xmlns:a="http://schemas.openxmlformats.org/drawingml/2006/main" prst="rect">
-            <a:avLst/>
-          </a:prstGeom>
-          <a:noFill xmlns:a="http://schemas.openxmlformats.org/drawingml/2006/main"/>
-          <a:ln xmlns:a="http://schemas.openxmlformats.org/drawingml/2006/main" w="0">
-            <a:noFill/>
-            <a:prstDash val="solid"/>
-          </a:ln>
-        </p:spPr>
-        <p:txBody>
-          <a:bodyPr xmlns:a="http://schemas.openxmlformats.org/drawingml/2006/main">
-            <a:normAutofit fontScale="98501"/>
-          </a:bodyPr>
-          <a:lstStyle xmlns:a="http://schemas.openxmlformats.org/drawingml/2006/main"/>
-          <a:p xmlns:a="http://schemas.openxmlformats.org/drawingml/2006/main">
-            <a:pPr>
-              <a:defRPr sz="3600" b="1">
-                <a:solidFill>
-                  <a:srgbClr val="000000"/>
-                </a:solidFill>
-                <a:latin typeface="Arial"/>
-                <a:ea typeface="Arial"/>
-                <a:cs typeface="Arial"/>
-              </a:defRPr>
-            </a:pPr>
-            <a:r>
-              <a:rPr sz="3600" b="1">
-                <a:solidFill>
-                  <a:srgbClr val="000000"/>
-                </a:solidFill>
-                <a:latin typeface="Arial"/>
-                <a:ea typeface="Arial"/>
-                <a:cs typeface="Arial"/>
-              </a:rPr>
-              <a:t>Noise alone is manageable; combined stress is not</a:t>
-            </a:r>
-          </a:p>
-        </p:txBody>
-      </p:sp>
-      <p:pic>
-        <p:nvPicPr>
-          <p:cNvPr id="6" name=""/>
-          <p:cNvPicPr>
-            <a:picLocks xmlns:a="http://schemas.openxmlformats.org/drawingml/2006/main" noChangeAspect="1"/>
-          </p:cNvPicPr>
-          <p:nvPr/>
-        </p:nvPicPr>
-        <p:blipFill>
-          <a:blip xmlns:r="http://schemas.openxmlformats.org/officeDocument/2006/relationships" xmlns:a="http://schemas.openxmlformats.org/drawingml/2006/main" r:embed="rId2"/>
-          <a:stretch xmlns:a="http://schemas.openxmlformats.org/drawingml/2006/main"/>
-        </p:blipFill>
-        <p:spPr>
-          <a:xfrm xmlns:a="http://schemas.openxmlformats.org/drawingml/2006/main">
-            <a:off x="5905500" y="1695364"/>
-            <a:ext cx="5715000" cy="3714922"/>
-          </a:xfrm>
-          <a:prstGeom xmlns:a="http://schemas.openxmlformats.org/drawingml/2006/main" prst="rect">
-            <a:avLst/>
-          </a:prstGeom>
-        </p:spPr>
-      </p:pic>
-      <p:sp>
-        <p:nvSpPr>
-          <p:cNvPr id="3" name="stochastic-claim">
-            <a:extLst xmlns:a="http://schemas.openxmlformats.org/drawingml/2006/main">
-              <a:ext uri="{FF2B5EF4-FFF2-40B4-BE49-F238E27FC236}">
-                <a16:creationId xmlns:a16="http://schemas.microsoft.com/office/drawing/2014/main" id="{00000000-0000-0000-0000-000000000030}"/>
-              </a:ext>
-            </a:extLst>
-          </p:cNvPr>
-          <p:cNvSpPr>
-            <a:spLocks xmlns:a="http://schemas.openxmlformats.org/drawingml/2006/main" noGrp="1"/>
-          </p:cNvSpPr>
-          <p:nvPr/>
-        </p:nvSpPr>
-        <p:spPr>
-          <a:xfrm xmlns:a="http://schemas.openxmlformats.org/drawingml/2006/main">
-            <a:off x="495300" y="1714500"/>
-            <a:ext cx="5143500" cy="1524000"/>
-          </a:xfrm>
-          <a:prstGeom xmlns:a="http://schemas.openxmlformats.org/drawingml/2006/main" prst="rect">
-            <a:avLst/>
-          </a:prstGeom>
-          <a:noFill xmlns:a="http://schemas.openxmlformats.org/drawingml/2006/main"/>
-          <a:ln xmlns:a="http://schemas.openxmlformats.org/drawingml/2006/main" w="0">
-            <a:noFill/>
-            <a:prstDash val="solid"/>
-          </a:ln>
-        </p:spPr>
-        <p:txBody>
-          <a:bodyPr xmlns:a="http://schemas.openxmlformats.org/drawingml/2006/main" anchor="t">
-            <a:normAutofit fontScale="100000"/>
-          </a:bodyPr>
-          <a:lstStyle xmlns:a="http://schemas.openxmlformats.org/drawingml/2006/main"/>
-          <a:p xmlns:a="http://schemas.openxmlformats.org/drawingml/2006/main">
-            <a:pPr algn="l">
-              <a:defRPr sz="2400" b="1">
-                <a:solidFill>
-                  <a:srgbClr val="000000"/>
-                </a:solidFill>
-                <a:latin typeface="Arial"/>
-                <a:ea typeface="Arial"/>
-                <a:cs typeface="Arial"/>
-              </a:defRPr>
-            </a:pPr>
-            <a:r>
-              <a:rPr sz="2400" b="1">
-                <a:solidFill>
-                  <a:srgbClr val="000000"/>
-                </a:solidFill>
-                <a:latin typeface="Arial"/>
-                <a:ea typeface="Arial"/>
-                <a:cs typeface="Arial"/>
-              </a:rPr>
-              <a:t>Each isolated-noise cell passes 30/30 paired trials, while every combined-stress cell passes 0/30.</a:t>
-            </a:r>
-          </a:p>
-        </p:txBody>
-      </p:sp>
-      <p:sp>
-        <p:nvSpPr>
-          <p:cNvPr id="4" name="stochastic-body">
-            <a:extLst xmlns:a="http://schemas.openxmlformats.org/drawingml/2006/main">
-              <a:ext uri="{FF2B5EF4-FFF2-40B4-BE49-F238E27FC236}">
-                <a16:creationId xmlns:a16="http://schemas.microsoft.com/office/drawing/2014/main" id="{00000000-0000-0000-0000-000000000031}"/>
-              </a:ext>
-            </a:extLst>
-          </p:cNvPr>
-          <p:cNvSpPr>
-            <a:spLocks xmlns:a="http://schemas.openxmlformats.org/drawingml/2006/main" noGrp="1"/>
-          </p:cNvSpPr>
-          <p:nvPr/>
-        </p:nvSpPr>
-        <p:spPr>
-          <a:xfrm xmlns:a="http://schemas.openxmlformats.org/drawingml/2006/main">
-            <a:off x="495300" y="3429000"/>
-            <a:ext cx="5143500" cy="2362200"/>
-          </a:xfrm>
-          <a:prstGeom xmlns:a="http://schemas.openxmlformats.org/drawingml/2006/main" prst="rect">
-            <a:avLst/>
-          </a:prstGeom>
-          <a:noFill xmlns:a="http://schemas.openxmlformats.org/drawingml/2006/main"/>
-          <a:ln xmlns:a="http://schemas.openxmlformats.org/drawingml/2006/main" w="0">
-            <a:noFill/>
-            <a:prstDash val="solid"/>
-          </a:ln>
-        </p:spPr>
-        <p:txBody>
-          <a:bodyPr xmlns:a="http://schemas.openxmlformats.org/drawingml/2006/main" anchor="t">
-            <a:normAutofit fontScale="100000"/>
-          </a:bodyPr>
-          <a:lstStyle xmlns:a="http://schemas.openxmlformats.org/drawingml/2006/main"/>
-          <a:p xmlns:a="http://schemas.openxmlformats.org/drawingml/2006/main">
-            <a:pPr algn="l">
-              <a:defRPr sz="1800" b="0">
-                <a:solidFill>
-                  <a:srgbClr val="000000"/>
-                </a:solidFill>
-                <a:latin typeface="Arial"/>
-                <a:ea typeface="Arial"/>
-                <a:cs typeface="Arial"/>
-              </a:defRPr>
-            </a:pPr>
-            <a:r>
-              <a:rPr sz="1800" b="0">
-                <a:solidFill>
-                  <a:srgbClr val="000000"/>
-                </a:solidFill>
-                <a:latin typeface="Arial"/>
-                <a:ea typeface="Arial"/>
-                <a:cs typeface="Arial"/>
-              </a:rPr>
-              <a:t>The full study contains 360 trials: 4 scenarios x 3 controllers x 30 fixed seeds.</a:t>
-            </a:r>
-          </a:p>
-          <a:p xmlns:a="http://schemas.openxmlformats.org/drawingml/2006/main">
-            <a:r>
-              <a:t/>
-            </a:r>
-          </a:p>
-          <a:p xmlns:a="http://schemas.openxmlformats.org/drawingml/2006/main">
-            <a:pPr algn="l">
-              <a:defRPr sz="1800" b="0">
-                <a:solidFill>
-                  <a:srgbClr val="000000"/>
-                </a:solidFill>
-                <a:latin typeface="Arial"/>
-                <a:ea typeface="Arial"/>
-                <a:cs typeface="Arial"/>
-              </a:defRPr>
-            </a:pPr>
-            <a:r>
-              <a:rPr sz="1800" b="0">
-                <a:solidFill>
-                  <a:srgbClr val="000000"/>
-                </a:solidFill>
-                <a:latin typeface="Arial"/>
-                <a:ea typeface="Arial"/>
-                <a:cs typeface="Arial"/>
-              </a:rPr>
-              <a:t>At high noise, optimized PID has the lowest tracking error but the highest mean torque slew (2888.34 N m/s).</a:t>
-            </a:r>
-          </a:p>
-        </p:txBody>
-      </p:sp>
-    </p:spTree>
-    <p:extLst>
-      <p:ext uri="{BB962C8B-B14F-4D97-AF65-F5344CB8AC3E}">
-        <p14:creationId xmlns:p14="http://schemas.microsoft.com/office/powerpoint/2010/main" val="32"/>
-      </p:ext>
-    </p:extLst>
-  </p:cSld>
-</p:sld>
+<ns0:sld xmlns:ns0="http://schemas.openxmlformats.org/presentationml/2006/main" xmlns:ns1="http://schemas.openxmlformats.org/drawingml/2006/main" xmlns:ns2="http://schemas.microsoft.com/office/drawing/2014/main" xmlns:ns3="http://schemas.openxmlformats.org/officeDocument/2006/relationships" xmlns:ns4="http://schemas.microsoft.com/office/powerpoint/2010/main">
+  <ns0:cSld>
+    <ns0:bg>
+      <ns0:bgPr>
+        <ns1:solidFill>
+          <ns1:srgbClr val="FFFFFF"/>
+        </ns1:solidFill>
+      </ns0:bgPr>
+    </ns0:bg>
+    <ns0:spTree>
+      <ns0:nvGrpSpPr>
+        <ns0:cNvPr id="1" name=""/>
+        <ns0:cNvGrpSpPr/>
+        <ns0:nvPr/>
+      </ns0:nvGrpSpPr>
+      <ns0:grpSpPr>
+        <ns1:xfrm/>
+      </ns0:grpSpPr>
+      <ns0:sp>
+        <ns0:nvSpPr>
+          <ns0:cNvPr id="5" name="slide-6-title">
+            <ns1:extLst>
+              <ns1:ext uri="{FF2B5EF4-FFF2-40B4-BE49-F238E27FC236}">
+                <ns2:creationId id="{00000000-0000-0000-0000-000000000029}"/>
+              </ns1:ext>
+            </ns1:extLst>
+          </ns0:cNvPr>
+          <ns0:cNvSpPr>
+            <ns1:spLocks noGrp="1"/>
+          </ns0:cNvSpPr>
+          <ns0:nvPr/>
+        </ns0:nvSpPr>
+        <ns0:spPr>
+          <ns1:xfrm>
+            <ns1:off x="495300" y="323850"/>
+            <ns1:ext cx="11125200" cy="685800"/>
+          </ns1:xfrm>
+          <ns1:prstGeom prst="rect">
+            <ns1:avLst/>
+          </ns1:prstGeom>
+          <ns1:noFill/>
+          <ns1:ln w="0">
+            <ns1:noFill/>
+            <ns1:prstDash val="solid"/>
+          </ns1:ln>
+        </ns0:spPr>
+        <ns0:txBody>
+          <ns1:bodyPr>
+            <ns1:normAutofit fontScale="98501"/>
+          </ns1:bodyPr>
+          <ns1:lstStyle/>
+          <ns1:p>
+            <ns1:pPr>
+              <ns1:defRPr sz="3600" b="1">
+                <ns1:solidFill>
+                  <ns1:srgbClr val="000000"/>
+                </ns1:solidFill>
+                <ns1:latin typeface="Arial"/>
+                <ns1:ea typeface="Arial"/>
+                <ns1:cs typeface="Arial"/>
+              </ns1:defRPr>
+            </ns1:pPr>
+            <ns1:r>
+              <ns1:rPr sz="3600" b="1">
+                <ns1:solidFill>
+                  <ns1:srgbClr val="000000"/>
+                </ns1:solidFill>
+                <ns1:latin typeface="Arial"/>
+                <ns1:ea typeface="Arial"/>
+                <ns1:cs typeface="Arial"/>
+              </ns1:rPr>
+              <ns1:t>Noise alone is manageable; combined stress is not</ns1:t>
+            </ns1:r>
+          </ns1:p>
+        </ns0:txBody>
+      </ns0:sp>
+      <ns0:pic>
+        <ns0:nvPicPr>
+          <ns0:cNvPr id="6" name=""/>
+          <ns0:cNvPicPr>
+            <ns1:picLocks noChangeAspect="1"/>
+          </ns0:cNvPicPr>
+          <ns0:nvPr/>
+        </ns0:nvPicPr>
+        <ns0:blipFill>
+          <ns1:blip ns3:embed="rId2"/>
+          <ns1:stretch/>
+        </ns0:blipFill>
+        <ns0:spPr>
+          <ns1:xfrm>
+            <ns1:off x="5905500" y="1695364"/>
+            <ns1:ext cx="5715000" cy="3714922"/>
+          </ns1:xfrm>
+          <ns1:prstGeom prst="rect">
+            <ns1:avLst/>
+          </ns1:prstGeom>
+        </ns0:spPr>
+      </ns0:pic>
+      <ns0:sp>
+        <ns0:nvSpPr>
+          <ns0:cNvPr id="3" name="stochastic-claim">
+            <ns1:extLst>
+              <ns1:ext uri="{FF2B5EF4-FFF2-40B4-BE49-F238E27FC236}">
+                <ns2:creationId id="{00000000-0000-0000-0000-000000000030}"/>
+              </ns1:ext>
+            </ns1:extLst>
+          </ns0:cNvPr>
+          <ns0:cNvSpPr>
+            <ns1:spLocks noGrp="1"/>
+          </ns0:cNvSpPr>
+          <ns0:nvPr/>
+        </ns0:nvSpPr>
+        <ns0:spPr>
+          <ns1:xfrm>
+            <ns1:off x="495300" y="1714500"/>
+            <ns1:ext cx="5143500" cy="1524000"/>
+          </ns1:xfrm>
+          <ns1:prstGeom prst="rect">
+            <ns1:avLst/>
+          </ns1:prstGeom>
+          <ns1:noFill/>
+          <ns1:ln w="0">
+            <ns1:noFill/>
+            <ns1:prstDash val="solid"/>
+          </ns1:ln>
+        </ns0:spPr>
+        <ns0:txBody>
+          <ns1:bodyPr anchor="t">
+            <ns1:normAutofit fontScale="100000"/>
+          </ns1:bodyPr>
+          <ns1:lstStyle/>
+          <ns1:p>
+            <ns1:pPr algn="l">
+              <ns1:defRPr sz="2400" b="1">
+                <ns1:solidFill>
+                  <ns1:srgbClr val="000000"/>
+                </ns1:solidFill>
+                <ns1:latin typeface="Arial"/>
+                <ns1:ea typeface="Arial"/>
+                <ns1:cs typeface="Arial"/>
+              </ns1:defRPr>
+            </ns1:pPr>
+            <ns1:r>
+              <ns1:rPr sz="2400" b="1">
+                <ns1:solidFill>
+                  <ns1:srgbClr val="000000"/>
+                </ns1:solidFill>
+                <ns1:latin typeface="Arial"/>
+                <ns1:ea typeface="Arial"/>
+                <ns1:cs typeface="Arial"/>
+              </ns1:rPr>
+              <ns1:t>Each isolated-noise cell passes 30/30 paired trials, while every combined-stress cell passes 0/30.</ns1:t>
+            </ns1:r>
+          </ns1:p>
+        </ns0:txBody>
+      </ns0:sp>
+      <ns0:sp>
+        <ns0:nvSpPr>
+          <ns0:cNvPr id="4" name="stochastic-body">
+            <ns1:extLst>
+              <ns1:ext uri="{FF2B5EF4-FFF2-40B4-BE49-F238E27FC236}">
+                <ns2:creationId id="{00000000-0000-0000-0000-000000000031}"/>
+              </ns1:ext>
+            </ns1:extLst>
+          </ns0:cNvPr>
+          <ns0:cNvSpPr>
+            <ns1:spLocks noGrp="1"/>
+          </ns0:cNvSpPr>
+          <ns0:nvPr/>
+        </ns0:nvSpPr>
+        <ns0:spPr>
+          <ns1:xfrm>
+            <ns1:off x="495300" y="3429000"/>
+            <ns1:ext cx="5143500" cy="2362200"/>
+          </ns1:xfrm>
+          <ns1:prstGeom prst="rect">
+            <ns1:avLst/>
+          </ns1:prstGeom>
+          <ns1:noFill/>
+          <ns1:ln w="0">
+            <ns1:noFill/>
+            <ns1:prstDash val="solid"/>
+          </ns1:ln>
+        </ns0:spPr>
+        <ns0:txBody>
+          <ns1:bodyPr anchor="t">
+            <ns1:normAutofit fontScale="100000"/>
+          </ns1:bodyPr>
+          <ns1:lstStyle/>
+          <ns1:p>
+            <ns1:pPr algn="l">
+              <ns1:defRPr sz="1800" b="0">
+                <ns1:solidFill>
+                  <ns1:srgbClr val="000000"/>
+                </ns1:solidFill>
+                <ns1:latin typeface="Arial"/>
+                <ns1:ea typeface="Arial"/>
+                <ns1:cs typeface="Arial"/>
+              </ns1:defRPr>
+            </ns1:pPr>
+            <ns1:r>
+              <ns1:rPr sz="1800" b="0">
+                <ns1:solidFill>
+                  <ns1:srgbClr val="000000"/>
+                </ns1:solidFill>
+                <ns1:latin typeface="Arial"/>
+                <ns1:ea typeface="Arial"/>
+                <ns1:cs typeface="Arial"/>
+              </ns1:rPr>
+              <ns1:t>Study: 360 trials (4 scenarios x 3 controllers x 30 fixed seeds).</ns1:t>
+            </ns1:r>
+          </ns1:p>
+          <ns1:p>
+            <ns1:r>
+              <ns1:t/>
+            </ns1:r>
+          </ns1:p>
+          <ns1:p>
+            <ns1:pPr algn="l">
+              <ns1:defRPr sz="1800" b="0">
+                <ns1:solidFill>
+                  <ns1:srgbClr val="000000"/>
+                </ns1:solidFill>
+                <ns1:latin typeface="Arial"/>
+                <ns1:ea typeface="Arial"/>
+                <ns1:cs typeface="Arial"/>
+              </ns1:defRPr>
+            </ns1:pPr>
+            <ns1:r>
+              <ns1:rPr sz="1800" b="0">
+                <ns1:solidFill>
+                  <ns1:srgbClr val="000000"/>
+                </ns1:solidFill>
+                <ns1:latin typeface="Arial"/>
+                <ns1:ea typeface="Arial"/>
+                <ns1:cs typeface="Arial"/>
+              </ns1:rPr>
+              <ns1:t>At high noise, optimized PID has the lowest tracking error but the highest mean torque slew (2888.34 N m/s).</ns1:t>
+            </ns1:r>
+          </ns1:p>
+        </ns0:txBody>
+      </ns0:sp>
+    </ns0:spTree>
+    <ns0:extLst>
+      <ns0:ext uri="{BB962C8B-B14F-4D97-AF65-F5344CB8AC3E}">
+        <ns4:creationId val="32"/>
+      </ns0:ext>
+    </ns0:extLst>
+  </ns0:cSld>
+</ns0:sld>
 </file>
 
 <file path=ppt/slides/slide7.xml><?xml version="1.0" encoding="utf-8"?>
@@ -4670,7 +4670,7 @@
           <a:lstStyle xmlns:a="http://schemas.openxmlformats.org/drawingml/2006/main"/>
           <a:p xmlns:a="http://schemas.openxmlformats.org/drawingml/2006/main">
             <a:pPr>
-              <a:defRPr sz="2700" b="1">
+              <a:defRPr sz="3600" b="1">
                 <a:solidFill>
                   <a:srgbClr val="000000"/>
                 </a:solidFill>
@@ -4680,7 +4680,7 @@
               </a:defRPr>
             </a:pPr>
             <a:r>
-              <a:rPr sz="2700" b="1">
+              <a:rPr sz="3600" b="1">
                 <a:solidFill>
                   <a:srgbClr val="000000"/>
                 </a:solidFill>
@@ -4688,30 +4688,7 @@
                 <a:ea typeface="Arial"/>
                 <a:cs typeface="Arial"/>
               </a:rPr>
-              <a:t>There is no universal winner, but</a:t>
-            </a:r>
-          </a:p>
-          <a:p xmlns:a="http://schemas.openxmlformats.org/drawingml/2006/main">
-            <a:pPr>
-              <a:defRPr sz="2700" b="1">
-                <a:solidFill>
-                  <a:srgbClr val="000000"/>
-                </a:solidFill>
-                <a:latin typeface="Arial"/>
-                <a:ea typeface="Arial"/>
-                <a:cs typeface="Arial"/>
-              </a:defRPr>
-            </a:pPr>
-            <a:r>
-              <a:rPr sz="2700" b="1">
-                <a:solidFill>
-                  <a:srgbClr val="000000"/>
-                </a:solidFill>
-                <a:latin typeface="Arial"/>
-                <a:ea typeface="Arial"/>
-                <a:cs typeface="Arial"/>
-              </a:rPr>
-              <a:t>optimized PID is the strongest reliability baseline</a:t>
+              <a:t>Optimized PID is the strongest reliability baseline</a:t>
             </a:r>
           </a:p>
         </p:txBody>

</xml_diff>

<commit_message>
fix: harden Phase 7B final review gates
</commit_message>
<xml_diff>
--- a/presentation/final_presentation.pptx
+++ b/presentation/final_presentation.pptx
@@ -1982,7 +1982,7 @@
         </p:spPr>
         <p:txBody>
           <a:bodyPr xmlns:a="http://schemas.openxmlformats.org/drawingml/2006/main" anchor="t">
-            <a:normAutofit fontScale="81863"/>
+            <a:normAutofit fontScale="100000"/>
           </a:bodyPr>
           <a:lstStyle xmlns:a="http://schemas.openxmlformats.org/drawingml/2006/main"/>
           <a:p xmlns:a="http://schemas.openxmlformats.org/drawingml/2006/main">
@@ -2005,7 +2005,7 @@
                 <a:ea typeface="Arial"/>
                 <a:cs typeface="Arial"/>
               </a:rPr>
-              <a:t>Reliable execution connects plans to physical action</a:t>
+              <a:t>Reliable control enables action</a:t>
             </a:r>
           </a:p>
         </p:txBody>
@@ -2386,7 +2386,7 @@
         </p:spPr>
         <p:txBody>
           <a:bodyPr xmlns:a="http://schemas.openxmlformats.org/drawingml/2006/main">
-            <a:normAutofit fontScale="81563"/>
+            <a:normAutofit fontScale="100000"/>
           </a:bodyPr>
           <a:lstStyle xmlns:a="http://schemas.openxmlformats.org/drawingml/2006/main"/>
           <a:p xmlns:a="http://schemas.openxmlformats.org/drawingml/2006/main">
@@ -2409,7 +2409,7 @@
                 <a:ea typeface="Arial"/>
                 <a:cs typeface="Arial"/>
               </a:rPr>
-              <a:t>Nominal success is not enough to claim reliable manipulation</a:t>
+              <a:t>Nominal success does not prove reliable manipulation</a:t>
             </a:r>
           </a:p>
         </p:txBody>
@@ -2466,7 +2466,7 @@
         </p:spPr>
         <p:txBody>
           <a:bodyPr xmlns:a="http://schemas.openxmlformats.org/drawingml/2006/main" anchor="t">
-            <a:normAutofit fontScale="89980"/>
+            <a:normAutofit fontScale="100000"/>
           </a:bodyPr>
           <a:lstStyle xmlns:a="http://schemas.openxmlformats.org/drawingml/2006/main"/>
           <a:p xmlns:a="http://schemas.openxmlformats.org/drawingml/2006/main">
@@ -2489,7 +2489,7 @@
                 <a:ea typeface="Arial"/>
                 <a:cs typeface="Arial"/>
               </a:rPr>
-              <a:t>The central question is how controller choices survive controlled changes in payload, configuration, noise, disturbance, and actuator authority.</a:t>
+              <a:t>Controller choice must survive changes in payload, configuration, noise, disturbance, and actuator authority.</a:t>
             </a:r>
           </a:p>
         </p:txBody>
@@ -2667,7 +2667,7 @@
         </p:spPr>
         <p:txBody>
           <a:bodyPr xmlns:a="http://schemas.openxmlformats.org/drawingml/2006/main">
-            <a:normAutofit fontScale="74530"/>
+            <a:normAutofit fontScale="100000"/>
           </a:bodyPr>
           <a:lstStyle xmlns:a="http://schemas.openxmlformats.org/drawingml/2006/main"/>
           <a:p xmlns:a="http://schemas.openxmlformats.org/drawingml/2006/main">
@@ -2690,7 +2690,7 @@
                 <a:ea typeface="Arial"/>
                 <a:cs typeface="Arial"/>
               </a:rPr>
-              <a:t>Every controller faces the same plant, trajectory, limits, and metrics</a:t>
+              <a:t>Every controller follows the same protocol</a:t>
             </a:r>
           </a:p>
         </p:txBody>
@@ -3160,7 +3160,7 @@
         </p:spPr>
         <p:txBody>
           <a:bodyPr xmlns:a="http://schemas.openxmlformats.org/drawingml/2006/main">
-            <a:normAutofit fontScale="75920"/>
+            <a:normAutofit fontScale="100000"/>
           </a:bodyPr>
           <a:lstStyle xmlns:a="http://schemas.openxmlformats.org/drawingml/2006/main"/>
           <a:p xmlns:a="http://schemas.openxmlformats.org/drawingml/2006/main">
@@ -3183,7 +3183,7 @@
                 <a:ea typeface="Arial"/>
                 <a:cs typeface="Arial"/>
               </a:rPr>
-              <a:t>Optimization improves the baseline without changing the protocol</a:t>
+              <a:t>Optimization improves PID under a fixed protocol</a:t>
             </a:r>
           </a:p>
         </p:txBody>
@@ -3240,7 +3240,7 @@
         </p:spPr>
         <p:txBody>
           <a:bodyPr xmlns:a="http://schemas.openxmlformats.org/drawingml/2006/main" anchor="t">
-            <a:normAutofit fontScale="94592"/>
+            <a:normAutofit fontScale="100000"/>
           </a:bodyPr>
           <a:lstStyle xmlns:a="http://schemas.openxmlformats.org/drawingml/2006/main"/>
           <a:p xmlns:a="http://schemas.openxmlformats.org/drawingml/2006/main">
@@ -3263,7 +3263,7 @@
                 <a:ea typeface="Arial"/>
                 <a:cs typeface="Arial"/>
               </a:rPr>
-              <a:t>The bounded search reduces the nominal objective by 7.283% and improves the held-out payload objective from 0.214504 to 0.197284.</a:t>
+              <a:t>Optimization lowers the nominal objective 7.283% and the held-out payload objective from 0.214504 to 0.197284.</a:t>
             </a:r>
           </a:p>
         </p:txBody>
@@ -3413,7 +3413,7 @@
         </p:spPr>
         <p:txBody>
           <a:bodyPr xmlns:a="http://schemas.openxmlformats.org/drawingml/2006/main">
-            <a:normAutofit fontScale="80599"/>
+            <a:normAutofit fontScale="100000"/>
           </a:bodyPr>
           <a:lstStyle xmlns:a="http://schemas.openxmlformats.org/drawingml/2006/main"/>
           <a:p xmlns:a="http://schemas.openxmlformats.org/drawingml/2006/main">
@@ -3436,7 +3436,7 @@
                 <a:ea typeface="Arial"/>
                 <a:cs typeface="Arial"/>
               </a:rPr>
-              <a:t>Reliability separates the controllers under deterministic stress</a:t>
+              <a:t>Deterministic stress separates controller reliability</a:t>
             </a:r>
           </a:p>
         </p:txBody>
@@ -3919,7 +3919,7 @@
         </p:spPr>
         <p:txBody>
           <a:bodyPr xmlns:a="http://schemas.openxmlformats.org/drawingml/2006/main">
-            <a:normAutofit fontScale="79861"/>
+            <a:normAutofit fontScale="100000"/>
           </a:bodyPr>
           <a:lstStyle xmlns:a="http://schemas.openxmlformats.org/drawingml/2006/main"/>
           <a:p xmlns:a="http://schemas.openxmlformats.org/drawingml/2006/main">
@@ -3942,7 +3942,7 @@
                 <a:ea typeface="Arial"/>
                 <a:cs typeface="Arial"/>
               </a:rPr>
-              <a:t>Task-space evaluation exposes failures hidden by joint metrics</a:t>
+              <a:t>Task-space tests expose hidden failures</a:t>
             </a:r>
           </a:p>
         </p:txBody>
@@ -3999,7 +3999,7 @@
         </p:spPr>
         <p:txBody>
           <a:bodyPr xmlns:a="http://schemas.openxmlformats.org/drawingml/2006/main" anchor="t">
-            <a:normAutofit fontScale="91267"/>
+            <a:normAutofit fontScale="100000"/>
           </a:bodyPr>
           <a:lstStyle xmlns:a="http://schemas.openxmlformats.org/drawingml/2006/main"/>
           <a:p xmlns:a="http://schemas.openxmlformats.org/drawingml/2006/main">
@@ -4022,7 +4022,7 @@
                 <a:ea typeface="Arial"/>
                 <a:cs typeface="Arial"/>
               </a:rPr>
-              <a:t>All 3 controllers pass the straight-line task; only optimized PID passes pick-transfer-place, so 4 of 6 completed task runs meet every gate.</a:t>
+              <a:t>All 3 controllers pass straight-line; only optimized PID passes pick-transfer-place, so 4 of 6 task runs pass every gate.</a:t>
             </a:r>
           </a:p>
         </p:txBody>
@@ -4172,7 +4172,7 @@
         </p:spPr>
         <p:txBody>
           <a:bodyPr xmlns:a="http://schemas.openxmlformats.org/drawingml/2006/main">
-            <a:normAutofit fontScale="91780"/>
+            <a:normAutofit fontScale="100000"/>
           </a:bodyPr>
           <a:lstStyle xmlns:a="http://schemas.openxmlformats.org/drawingml/2006/main"/>
           <a:p xmlns:a="http://schemas.openxmlformats.org/drawingml/2006/main">
@@ -4195,7 +4195,7 @@
                 <a:ea typeface="Arial"/>
                 <a:cs typeface="Arial"/>
               </a:rPr>
-              <a:t>Independent formulations agree at numerical precision</a:t>
+              <a:t>Independent formulations agree numerically</a:t>
             </a:r>
           </a:p>
         </p:txBody>

</xml_diff>